<commit_message>
more work done on the presentation
</commit_message>
<xml_diff>
--- a/icfd2026/pres/kyushu_ppt_16-9.pptx
+++ b/icfd2026/pres/kyushu_ppt_16-9.pptx
@@ -5,18 +5,21 @@
     <p:sldMasterId id="2147483648" r:id="rId4"/>
   </p:sldMasterIdLst>
   <p:notesMasterIdLst>
-    <p:notesMasterId r:id="rId11"/>
+    <p:notesMasterId r:id="rId14"/>
   </p:notesMasterIdLst>
   <p:handoutMasterIdLst>
-    <p:handoutMasterId r:id="rId12"/>
+    <p:handoutMasterId r:id="rId15"/>
   </p:handoutMasterIdLst>
   <p:sldIdLst>
     <p:sldId id="260" r:id="rId5"/>
     <p:sldId id="262" r:id="rId6"/>
-    <p:sldId id="263" r:id="rId7"/>
-    <p:sldId id="268" r:id="rId8"/>
-    <p:sldId id="266" r:id="rId9"/>
-    <p:sldId id="269" r:id="rId10"/>
+    <p:sldId id="270" r:id="rId7"/>
+    <p:sldId id="263" r:id="rId8"/>
+    <p:sldId id="268" r:id="rId9"/>
+    <p:sldId id="266" r:id="rId10"/>
+    <p:sldId id="271" r:id="rId11"/>
+    <p:sldId id="272" r:id="rId12"/>
+    <p:sldId id="273" r:id="rId13"/>
   </p:sldIdLst>
   <p:sldSz cx="12192000" cy="6858000"/>
   <p:notesSz cx="9144000" cy="6858000"/>
@@ -258,7 +261,7 @@
               <a:pPr>
                 <a:defRPr/>
               </a:pPr>
-              <a:t>2026/10/7</a:t>
+              <a:t>2026/10/14</a:t>
             </a:fld>
             <a:endParaRPr lang="ja-JP" altLang="en-US"/>
           </a:p>
@@ -3649,6 +3652,24 @@
           <a:bodyPr/>
           <a:lstStyle/>
           <a:p>
+            <a:r>
+              <a:rPr lang="en-GB" dirty="0"/>
+              <a:t>Numerically simulating ammonia blends is necessary for combustion system development.</a:t>
+            </a:r>
+          </a:p>
+          <a:p>
+            <a:r>
+              <a:rPr lang="en-GB" dirty="0"/>
+              <a:t>Large-scale or 3D modelling with detailed chemical kinetics mechanisms increases computational cost.</a:t>
+            </a:r>
+          </a:p>
+          <a:p>
+            <a:r>
+              <a:rPr lang="en-GB" dirty="0"/>
+              <a:t>Reduced chemical kinetic mechanisms optimized for multiple ammonia blends and operating conditions is needed.</a:t>
+            </a:r>
+          </a:p>
+          <a:p>
             <a:endParaRPr lang="en-GB" dirty="0"/>
           </a:p>
         </p:txBody>
@@ -3733,6 +3754,236 @@
 </file>
 
 <file path=ppt/slides/slide3.xml><?xml version="1.0" encoding="utf-8"?>
+<p:sld xmlns:a="http://schemas.openxmlformats.org/drawingml/2006/main" xmlns:r="http://schemas.openxmlformats.org/officeDocument/2006/relationships" xmlns:p="http://schemas.openxmlformats.org/presentationml/2006/main">
+  <p:cSld>
+    <p:spTree>
+      <p:nvGrpSpPr>
+        <p:cNvPr id="1" name=""/>
+        <p:cNvGrpSpPr/>
+        <p:nvPr/>
+      </p:nvGrpSpPr>
+      <p:grpSpPr>
+        <a:xfrm>
+          <a:off x="0" y="0"/>
+          <a:ext cx="0" cy="0"/>
+          <a:chOff x="0" y="0"/>
+          <a:chExt cx="0" cy="0"/>
+        </a:xfrm>
+      </p:grpSpPr>
+      <mc:AlternateContent xmlns:mc="http://schemas.openxmlformats.org/markup-compatibility/2006">
+        <mc:Choice xmlns:a14="http://schemas.microsoft.com/office/drawing/2010/main" Requires="a14">
+          <p:sp>
+            <p:nvSpPr>
+              <p:cNvPr id="2" name="Content Placeholder 1">
+                <a:extLst>
+                  <a:ext uri="{FF2B5EF4-FFF2-40B4-BE49-F238E27FC236}">
+                    <a16:creationId xmlns:a16="http://schemas.microsoft.com/office/drawing/2014/main" id="{CBBCF3C5-C505-2F53-DE0B-D375D6591BD1}"/>
+                  </a:ext>
+                </a:extLst>
+              </p:cNvPr>
+              <p:cNvSpPr>
+                <a:spLocks noGrp="1"/>
+              </p:cNvSpPr>
+              <p:nvPr>
+                <p:ph idx="1"/>
+              </p:nvPr>
+            </p:nvSpPr>
+            <p:spPr/>
+            <p:txBody>
+              <a:bodyPr/>
+              <a:lstStyle/>
+              <a:p>
+                <a:r>
+                  <a:rPr lang="en-US" dirty="0"/>
+                  <a:t>Okafor et al.’s reduced mechanism (2019) accurately models NH3/air, NH3/CH4/air and H2/air flames.</a:t>
+                </a:r>
+              </a:p>
+              <a:p>
+                <a:r>
+                  <a:rPr lang="en-US" dirty="0"/>
+                  <a:t>Okafor et al.’s reduced mechanism (2019) fails to model NH3/H2/air flame when H2 concentration becomes significant (</a:t>
+                </a:r>
+                <a14:m>
+                  <m:oMath xmlns:m="http://schemas.openxmlformats.org/officeDocument/2006/math">
+                    <m:sSub>
+                      <m:sSubPr>
+                        <m:ctrlPr>
+                          <a:rPr lang="en-US" b="0" smtClean="0">
+                            <a:latin typeface="Cambria Math" panose="02040503050406030204" pitchFamily="18" charset="0"/>
+                          </a:rPr>
+                        </m:ctrlPr>
+                      </m:sSubPr>
+                      <m:e>
+                        <m:r>
+                          <a:rPr lang="en-US" b="0" i="1" smtClean="0">
+                            <a:latin typeface="Cambria Math" panose="02040503050406030204" pitchFamily="18" charset="0"/>
+                          </a:rPr>
+                          <m:t>𝑋</m:t>
+                        </m:r>
+                      </m:e>
+                      <m:sub>
+                        <m:r>
+                          <m:rPr>
+                            <m:sty m:val="p"/>
+                          </m:rPr>
+                          <a:rPr lang="en-US" b="0" i="0" smtClean="0">
+                            <a:latin typeface="Cambria Math" panose="02040503050406030204" pitchFamily="18" charset="0"/>
+                          </a:rPr>
+                          <m:t>H</m:t>
+                        </m:r>
+                        <m:r>
+                          <a:rPr lang="en-US" b="0" i="0" smtClean="0">
+                            <a:latin typeface="Cambria Math" panose="02040503050406030204" pitchFamily="18" charset="0"/>
+                          </a:rPr>
+                          <m:t>2</m:t>
+                        </m:r>
+                      </m:sub>
+                    </m:sSub>
+                    <m:r>
+                      <a:rPr lang="en-US" b="0" i="0" smtClean="0">
+                        <a:latin typeface="Cambria Math" panose="02040503050406030204" pitchFamily="18" charset="0"/>
+                      </a:rPr>
+                      <m:t>&gt;0.3</m:t>
+                    </m:r>
+                  </m:oMath>
+                </a14:m>
+                <a:r>
+                  <a:rPr lang="en-US" dirty="0"/>
+                  <a:t>).</a:t>
+                </a:r>
+              </a:p>
+              <a:p>
+                <a:r>
+                  <a:rPr lang="en-US" dirty="0"/>
+                  <a:t>Studying ammonia and hydrogen kinetics in NH3/H2/air reaction pathways to rectify this discrepancy.</a:t>
+                </a:r>
+              </a:p>
+              <a:p>
+                <a:endParaRPr lang="en-US" dirty="0"/>
+              </a:p>
+            </p:txBody>
+          </p:sp>
+        </mc:Choice>
+        <mc:Fallback>
+          <p:sp>
+            <p:nvSpPr>
+              <p:cNvPr id="2" name="Content Placeholder 1">
+                <a:extLst>
+                  <a:ext uri="{FF2B5EF4-FFF2-40B4-BE49-F238E27FC236}">
+                    <a16:creationId xmlns:a16="http://schemas.microsoft.com/office/drawing/2014/main" id="{CBBCF3C5-C505-2F53-DE0B-D375D6591BD1}"/>
+                  </a:ext>
+                </a:extLst>
+              </p:cNvPr>
+              <p:cNvSpPr>
+                <a:spLocks noGrp="1" noRot="1" noChangeAspect="1" noMove="1" noResize="1" noEditPoints="1" noAdjustHandles="1" noChangeArrowheads="1" noChangeShapeType="1" noTextEdit="1"/>
+              </p:cNvSpPr>
+              <p:nvPr>
+                <p:ph idx="1"/>
+              </p:nvPr>
+            </p:nvSpPr>
+            <p:spPr>
+              <a:blipFill>
+                <a:blip r:embed="rId2"/>
+                <a:stretch>
+                  <a:fillRect l="-1683" t="-2168" r="-2552"/>
+                </a:stretch>
+              </a:blipFill>
+            </p:spPr>
+            <p:txBody>
+              <a:bodyPr/>
+              <a:lstStyle/>
+              <a:p>
+                <a:r>
+                  <a:rPr lang="en-US">
+                    <a:noFill/>
+                  </a:rPr>
+                  <a:t> </a:t>
+                </a:r>
+              </a:p>
+            </p:txBody>
+          </p:sp>
+        </mc:Fallback>
+      </mc:AlternateContent>
+      <p:sp>
+        <p:nvSpPr>
+          <p:cNvPr id="3" name="Footer Placeholder 2">
+            <a:extLst>
+              <a:ext uri="{FF2B5EF4-FFF2-40B4-BE49-F238E27FC236}">
+                <a16:creationId xmlns:a16="http://schemas.microsoft.com/office/drawing/2014/main" id="{EADF9EAA-9192-FDCC-4D2A-063BD1E6B9F5}"/>
+              </a:ext>
+            </a:extLst>
+          </p:cNvPr>
+          <p:cNvSpPr>
+            <a:spLocks noGrp="1"/>
+          </p:cNvSpPr>
+          <p:nvPr>
+            <p:ph type="ftr" sz="quarter" idx="10"/>
+          </p:nvPr>
+        </p:nvSpPr>
+        <p:spPr/>
+        <p:txBody>
+          <a:bodyPr/>
+          <a:lstStyle/>
+          <a:p>
+            <a:pPr algn="l">
+              <a:defRPr/>
+            </a:pPr>
+            <a:r>
+              <a:rPr lang="en-US" altLang="ja-JP" dirty="0"/>
+              <a:t>Background</a:t>
+            </a:r>
+          </a:p>
+        </p:txBody>
+      </p:sp>
+      <p:sp>
+        <p:nvSpPr>
+          <p:cNvPr id="4" name="Slide Number Placeholder 3">
+            <a:extLst>
+              <a:ext uri="{FF2B5EF4-FFF2-40B4-BE49-F238E27FC236}">
+                <a16:creationId xmlns:a16="http://schemas.microsoft.com/office/drawing/2014/main" id="{C8C7E90D-ACB7-2538-743D-6A32390C70A5}"/>
+              </a:ext>
+            </a:extLst>
+          </p:cNvPr>
+          <p:cNvSpPr>
+            <a:spLocks noGrp="1"/>
+          </p:cNvSpPr>
+          <p:nvPr>
+            <p:ph type="sldNum" sz="quarter" idx="11"/>
+          </p:nvPr>
+        </p:nvSpPr>
+        <p:spPr/>
+        <p:txBody>
+          <a:bodyPr/>
+          <a:lstStyle/>
+          <a:p>
+            <a:pPr>
+              <a:defRPr/>
+            </a:pPr>
+            <a:fld id="{F0030BFF-6758-4814-A89A-12C821A76488}" type="slidenum">
+              <a:rPr lang="en-US" altLang="ja-JP" smtClean="0"/>
+              <a:pPr>
+                <a:defRPr/>
+              </a:pPr>
+              <a:t>2</a:t>
+            </a:fld>
+            <a:endParaRPr lang="en-US" altLang="ja-JP"/>
+          </a:p>
+        </p:txBody>
+      </p:sp>
+    </p:spTree>
+    <p:extLst>
+      <p:ext uri="{BB962C8B-B14F-4D97-AF65-F5344CB8AC3E}">
+        <p14:creationId xmlns:p14="http://schemas.microsoft.com/office/powerpoint/2010/main" val="117637165"/>
+      </p:ext>
+    </p:extLst>
+  </p:cSld>
+  <p:clrMapOvr>
+    <a:masterClrMapping/>
+  </p:clrMapOvr>
+</p:sld>
+</file>
+
+<file path=ppt/slides/slide4.xml><?xml version="1.0" encoding="utf-8"?>
 <p:sld xmlns:a="http://schemas.openxmlformats.org/drawingml/2006/main" xmlns:r="http://schemas.openxmlformats.org/officeDocument/2006/relationships" xmlns:p="http://schemas.openxmlformats.org/presentationml/2006/main">
   <p:cSld>
     <p:spTree>
@@ -3862,7 +4113,7 @@
               <a:pPr>
                 <a:defRPr/>
               </a:pPr>
-              <a:t>2</a:t>
+              <a:t>3</a:t>
             </a:fld>
             <a:endParaRPr lang="en-US" altLang="ja-JP"/>
           </a:p>
@@ -3881,7 +4132,7 @@
 </p:sld>
 </file>
 
-<file path=ppt/slides/slide4.xml><?xml version="1.0" encoding="utf-8"?>
+<file path=ppt/slides/slide5.xml><?xml version="1.0" encoding="utf-8"?>
 <p:sld xmlns:a="http://schemas.openxmlformats.org/drawingml/2006/main" xmlns:r="http://schemas.openxmlformats.org/officeDocument/2006/relationships" xmlns:p="http://schemas.openxmlformats.org/presentationml/2006/main">
   <p:cSld>
     <p:spTree>
@@ -3984,7 +4235,7 @@
               <a:pPr>
                 <a:defRPr/>
               </a:pPr>
-              <a:t>3</a:t>
+              <a:t>4</a:t>
             </a:fld>
             <a:endParaRPr lang="en-US" altLang="ja-JP"/>
           </a:p>
@@ -4003,7 +4254,7 @@
 </p:sld>
 </file>
 
-<file path=ppt/slides/slide5.xml><?xml version="1.0" encoding="utf-8"?>
+<file path=ppt/slides/slide6.xml><?xml version="1.0" encoding="utf-8"?>
 <p:sld xmlns:a="http://schemas.openxmlformats.org/drawingml/2006/main" xmlns:r="http://schemas.openxmlformats.org/officeDocument/2006/relationships" xmlns:p="http://schemas.openxmlformats.org/presentationml/2006/main">
   <p:cSld>
     <p:spTree>
@@ -4182,7 +4433,7 @@
                 <a:pPr lvl="1"/>
                 <a:r>
                   <a:rPr lang="en-GB" dirty="0"/>
-                  <a:t>Fuel-oxidizer ration maintained at stoichiometric equivalence ratio</a:t>
+                  <a:t>Fuel-oxidizer ratio was maintained at stoichiometric equivalence ratio</a:t>
                 </a:r>
               </a:p>
             </p:txBody>
@@ -4218,7 +4469,7 @@
               <a:lstStyle/>
               <a:p>
                 <a:r>
-                  <a:rPr lang="en-GB">
+                  <a:rPr lang="en-US">
                     <a:noFill/>
                   </a:rPr>
                   <a:t> </a:t>
@@ -4288,7 +4539,7 @@
               <a:pPr>
                 <a:defRPr/>
               </a:pPr>
-              <a:t>4</a:t>
+              <a:t>5</a:t>
             </a:fld>
             <a:endParaRPr lang="en-US" altLang="ja-JP"/>
           </a:p>
@@ -4307,7 +4558,7 @@
 </p:sld>
 </file>
 
-<file path=ppt/slides/slide6.xml><?xml version="1.0" encoding="utf-8"?>
+<file path=ppt/slides/slide7.xml><?xml version="1.0" encoding="utf-8"?>
 <p:sld xmlns:a="http://schemas.openxmlformats.org/drawingml/2006/main" xmlns:r="http://schemas.openxmlformats.org/officeDocument/2006/relationships" xmlns:p="http://schemas.openxmlformats.org/presentationml/2006/main">
   <p:cSld>
     <p:spTree>
@@ -4324,12 +4575,171 @@
           <a:chExt cx="0" cy="0"/>
         </a:xfrm>
       </p:grpSpPr>
+      <mc:AlternateContent xmlns:mc="http://schemas.openxmlformats.org/markup-compatibility/2006">
+        <mc:Choice xmlns:a14="http://schemas.microsoft.com/office/drawing/2010/main" Requires="a14">
+          <p:sp>
+            <p:nvSpPr>
+              <p:cNvPr id="2" name="Content Placeholder 1">
+                <a:extLst>
+                  <a:ext uri="{FF2B5EF4-FFF2-40B4-BE49-F238E27FC236}">
+                    <a16:creationId xmlns:a16="http://schemas.microsoft.com/office/drawing/2014/main" id="{362D3022-0FF1-75D1-578B-FB3189588C27}"/>
+                  </a:ext>
+                </a:extLst>
+              </p:cNvPr>
+              <p:cNvSpPr>
+                <a:spLocks noGrp="1"/>
+              </p:cNvSpPr>
+              <p:nvPr>
+                <p:ph idx="1"/>
+              </p:nvPr>
+            </p:nvSpPr>
+            <p:spPr/>
+            <p:txBody>
+              <a:bodyPr/>
+              <a:lstStyle/>
+              <a:p>
+                <a:r>
+                  <a:rPr lang="en-US" dirty="0"/>
+                  <a:t>Present mechanism is based on the reduced mechanism developed by Okafor et al. (2019).</a:t>
+                </a:r>
+              </a:p>
+              <a:p>
+                <a:pPr lvl="1"/>
+                <a:r>
+                  <a:rPr lang="en-US" dirty="0"/>
+                  <a:t>This mechanism already satisfactorily models laminar burning velocity of NH3/air and NH3/CH4/air flame.</a:t>
+                </a:r>
+              </a:p>
+              <a:p>
+                <a:pPr lvl="1"/>
+                <a:r>
+                  <a:rPr lang="en-US" dirty="0"/>
+                  <a:t>Fails to model NH3/H2/air flames at hydrogen concentrations greater than </a:t>
+                </a:r>
+                <a14:m>
+                  <m:oMath xmlns:m="http://schemas.openxmlformats.org/officeDocument/2006/math">
+                    <m:sSub>
+                      <m:sSubPr>
+                        <m:ctrlPr>
+                          <a:rPr lang="en-US" i="1">
+                            <a:latin typeface="Cambria Math" panose="02040503050406030204" pitchFamily="18" charset="0"/>
+                          </a:rPr>
+                        </m:ctrlPr>
+                      </m:sSubPr>
+                      <m:e>
+                        <m:r>
+                          <a:rPr lang="en-US" i="1">
+                            <a:latin typeface="Cambria Math" panose="02040503050406030204" pitchFamily="18" charset="0"/>
+                          </a:rPr>
+                          <m:t>𝑋</m:t>
+                        </m:r>
+                      </m:e>
+                      <m:sub>
+                        <m:r>
+                          <m:rPr>
+                            <m:sty m:val="p"/>
+                          </m:rPr>
+                          <a:rPr lang="en-US">
+                            <a:latin typeface="Cambria Math" panose="02040503050406030204" pitchFamily="18" charset="0"/>
+                          </a:rPr>
+                          <m:t>H</m:t>
+                        </m:r>
+                        <m:r>
+                          <a:rPr lang="en-US">
+                            <a:latin typeface="Cambria Math" panose="02040503050406030204" pitchFamily="18" charset="0"/>
+                          </a:rPr>
+                          <m:t>2</m:t>
+                        </m:r>
+                      </m:sub>
+                    </m:sSub>
+                    <m:r>
+                      <a:rPr lang="en-US" b="0" i="0" smtClean="0">
+                        <a:latin typeface="Cambria Math" panose="02040503050406030204" pitchFamily="18" charset="0"/>
+                      </a:rPr>
+                      <m:t>=</m:t>
+                    </m:r>
+                    <m:r>
+                      <a:rPr lang="en-US">
+                        <a:latin typeface="Cambria Math" panose="02040503050406030204" pitchFamily="18" charset="0"/>
+                      </a:rPr>
+                      <m:t>0.3</m:t>
+                    </m:r>
+                  </m:oMath>
+                </a14:m>
+                <a:endParaRPr lang="en-US" dirty="0"/>
+              </a:p>
+              <a:p>
+                <a:endParaRPr lang="en-US" dirty="0"/>
+              </a:p>
+              <a:p>
+                <a:r>
+                  <a:rPr lang="en-US" dirty="0"/>
+                  <a:t>Reaction mechanism by Gotama et al. (2022) was used to study the differences in ammonia and hydrogen kinetics interaction.</a:t>
+                </a:r>
+              </a:p>
+              <a:p>
+                <a:pPr lvl="1"/>
+                <a:r>
+                  <a:rPr lang="en-US" dirty="0"/>
+                  <a:t>This mechanism was optimized for laminar burning velocity of NH3/H2/air flames.</a:t>
+                </a:r>
+              </a:p>
+              <a:p>
+                <a:pPr lvl="1"/>
+                <a:endParaRPr lang="en-US" dirty="0"/>
+              </a:p>
+              <a:p>
+                <a:endParaRPr lang="en-US" dirty="0"/>
+              </a:p>
+            </p:txBody>
+          </p:sp>
+        </mc:Choice>
+        <mc:Fallback>
+          <p:sp>
+            <p:nvSpPr>
+              <p:cNvPr id="2" name="Content Placeholder 1">
+                <a:extLst>
+                  <a:ext uri="{FF2B5EF4-FFF2-40B4-BE49-F238E27FC236}">
+                    <a16:creationId xmlns:a16="http://schemas.microsoft.com/office/drawing/2014/main" id="{362D3022-0FF1-75D1-578B-FB3189588C27}"/>
+                  </a:ext>
+                </a:extLst>
+              </p:cNvPr>
+              <p:cNvSpPr>
+                <a:spLocks noGrp="1" noRot="1" noChangeAspect="1" noMove="1" noResize="1" noEditPoints="1" noAdjustHandles="1" noChangeArrowheads="1" noChangeShapeType="1" noTextEdit="1"/>
+              </p:cNvSpPr>
+              <p:nvPr>
+                <p:ph idx="1"/>
+              </p:nvPr>
+            </p:nvSpPr>
+            <p:spPr>
+              <a:blipFill>
+                <a:blip r:embed="rId2"/>
+                <a:stretch>
+                  <a:fillRect l="-1683" t="-2168" r="-109"/>
+                </a:stretch>
+              </a:blipFill>
+            </p:spPr>
+            <p:txBody>
+              <a:bodyPr/>
+              <a:lstStyle/>
+              <a:p>
+                <a:r>
+                  <a:rPr lang="en-US">
+                    <a:noFill/>
+                  </a:rPr>
+                  <a:t> </a:t>
+                </a:r>
+              </a:p>
+            </p:txBody>
+          </p:sp>
+        </mc:Fallback>
+      </mc:AlternateContent>
       <p:sp>
         <p:nvSpPr>
-          <p:cNvPr id="2" name="Title 1">
+          <p:cNvPr id="3" name="Footer Placeholder 2">
             <a:extLst>
               <a:ext uri="{FF2B5EF4-FFF2-40B4-BE49-F238E27FC236}">
-                <a16:creationId xmlns:a16="http://schemas.microsoft.com/office/drawing/2014/main" id="{D3DB0ED6-DD33-AD4E-9C9A-E46DCABDE9F2}"/>
+                <a16:creationId xmlns:a16="http://schemas.microsoft.com/office/drawing/2014/main" id="{FD3B3B8E-6FEC-19F3-F26E-F023004FB6C6}"/>
               </a:ext>
             </a:extLst>
           </p:cNvPr>
@@ -4337,7 +4747,7 @@
             <a:spLocks noGrp="1"/>
           </p:cNvSpPr>
           <p:nvPr>
-            <p:ph type="title"/>
+            <p:ph type="ftr" sz="quarter" idx="10"/>
           </p:nvPr>
         </p:nvSpPr>
         <p:spPr/>
@@ -4345,84 +4755,22 @@
           <a:bodyPr/>
           <a:lstStyle/>
           <a:p>
-            <a:endParaRPr lang="en-GB"/>
+            <a:pPr algn="l">
+              <a:defRPr/>
+            </a:pPr>
+            <a:r>
+              <a:rPr lang="en-US" altLang="ja-JP" dirty="0"/>
+              <a:t>Development of the Present Mech</a:t>
+            </a:r>
           </a:p>
         </p:txBody>
       </p:sp>
-      <p:pic>
-        <p:nvPicPr>
-          <p:cNvPr id="8" name="Content Placeholder 7">
+      <p:sp>
+        <p:nvSpPr>
+          <p:cNvPr id="4" name="Slide Number Placeholder 3">
             <a:extLst>
               <a:ext uri="{FF2B5EF4-FFF2-40B4-BE49-F238E27FC236}">
-                <a16:creationId xmlns:a16="http://schemas.microsoft.com/office/drawing/2014/main" id="{BB73C2D4-D16E-F820-2DF7-BC3FBD1AC889}"/>
-              </a:ext>
-            </a:extLst>
-          </p:cNvPr>
-          <p:cNvPicPr>
-            <a:picLocks noGrp="1" noChangeAspect="1"/>
-          </p:cNvPicPr>
-          <p:nvPr>
-            <p:ph sz="half" idx="1"/>
-          </p:nvPr>
-        </p:nvPicPr>
-        <p:blipFill>
-          <a:blip r:embed="rId2" cstate="print">
-            <a:extLst>
-              <a:ext uri="{28A0092B-C50C-407E-A947-70E740481C1C}">
-                <a14:useLocalDpi xmlns:a14="http://schemas.microsoft.com/office/drawing/2010/main" val="0"/>
-              </a:ext>
-            </a:extLst>
-          </a:blip>
-          <a:srcRect/>
-          <a:stretch/>
-        </p:blipFill>
-        <p:spPr>
-          <a:xfrm>
-            <a:off x="407293" y="2529845"/>
-            <a:ext cx="5400675" cy="2877810"/>
-          </a:xfrm>
-        </p:spPr>
-      </p:pic>
-      <p:pic>
-        <p:nvPicPr>
-          <p:cNvPr id="11" name="Content Placeholder 10">
-            <a:extLst>
-              <a:ext uri="{FF2B5EF4-FFF2-40B4-BE49-F238E27FC236}">
-                <a16:creationId xmlns:a16="http://schemas.microsoft.com/office/drawing/2014/main" id="{A0ED1C77-5D87-34CA-13C1-EC656E4E381D}"/>
-              </a:ext>
-            </a:extLst>
-          </p:cNvPr>
-          <p:cNvPicPr>
-            <a:picLocks noGrp="1" noChangeAspect="1"/>
-          </p:cNvPicPr>
-          <p:nvPr>
-            <p:ph sz="half" idx="2"/>
-          </p:nvPr>
-        </p:nvPicPr>
-        <p:blipFill>
-          <a:blip r:embed="rId3" cstate="print">
-            <a:extLst>
-              <a:ext uri="{28A0092B-C50C-407E-A947-70E740481C1C}">
-                <a14:useLocalDpi xmlns:a14="http://schemas.microsoft.com/office/drawing/2010/main" val="0"/>
-              </a:ext>
-            </a:extLst>
-          </a:blip>
-          <a:srcRect/>
-          <a:stretch/>
-        </p:blipFill>
-        <p:spPr>
-          <a:xfrm>
-            <a:off x="6168057" y="2569566"/>
-            <a:ext cx="5616575" cy="2798368"/>
-          </a:xfrm>
-        </p:spPr>
-      </p:pic>
-      <p:sp>
-        <p:nvSpPr>
-          <p:cNvPr id="5" name="Slide Number Placeholder 4">
-            <a:extLst>
-              <a:ext uri="{FF2B5EF4-FFF2-40B4-BE49-F238E27FC236}">
-                <a16:creationId xmlns:a16="http://schemas.microsoft.com/office/drawing/2014/main" id="{CE9DF380-33FC-5D35-CF0C-81AF2E87DFD3}"/>
+                <a16:creationId xmlns:a16="http://schemas.microsoft.com/office/drawing/2014/main" id="{CA7B048D-6E76-ED81-8B3C-72D4BFF9F668}"/>
               </a:ext>
             </a:extLst>
           </p:cNvPr>
@@ -4441,23 +4789,88 @@
             <a:pPr>
               <a:defRPr/>
             </a:pPr>
-            <a:fld id="{5E160AE0-185D-4321-8E65-BC536618BE04}" type="slidenum">
+            <a:fld id="{F0030BFF-6758-4814-A89A-12C821A76488}" type="slidenum">
               <a:rPr lang="en-US" altLang="ja-JP" smtClean="0"/>
               <a:pPr>
                 <a:defRPr/>
               </a:pPr>
-              <a:t>5</a:t>
+              <a:t>6</a:t>
             </a:fld>
             <a:endParaRPr lang="en-US" altLang="ja-JP"/>
           </a:p>
         </p:txBody>
       </p:sp>
+    </p:spTree>
+    <p:extLst>
+      <p:ext uri="{BB962C8B-B14F-4D97-AF65-F5344CB8AC3E}">
+        <p14:creationId xmlns:p14="http://schemas.microsoft.com/office/powerpoint/2010/main" val="2944974317"/>
+      </p:ext>
+    </p:extLst>
+  </p:cSld>
+  <p:clrMapOvr>
+    <a:masterClrMapping/>
+  </p:clrMapOvr>
+</p:sld>
+</file>
+
+<file path=ppt/slides/slide8.xml><?xml version="1.0" encoding="utf-8"?>
+<p:sld xmlns:a="http://schemas.openxmlformats.org/drawingml/2006/main" xmlns:r="http://schemas.openxmlformats.org/officeDocument/2006/relationships" xmlns:p="http://schemas.openxmlformats.org/presentationml/2006/main">
+  <p:cSld>
+    <p:spTree>
+      <p:nvGrpSpPr>
+        <p:cNvPr id="1" name=""/>
+        <p:cNvGrpSpPr/>
+        <p:nvPr/>
+      </p:nvGrpSpPr>
+      <p:grpSpPr>
+        <a:xfrm>
+          <a:off x="0" y="0"/>
+          <a:ext cx="0" cy="0"/>
+          <a:chOff x="0" y="0"/>
+          <a:chExt cx="0" cy="0"/>
+        </a:xfrm>
+      </p:grpSpPr>
+      <p:pic>
+        <p:nvPicPr>
+          <p:cNvPr id="6" name="Content Placeholder 5">
+            <a:extLst>
+              <a:ext uri="{FF2B5EF4-FFF2-40B4-BE49-F238E27FC236}">
+                <a16:creationId xmlns:a16="http://schemas.microsoft.com/office/drawing/2014/main" id="{D794FDB1-5DD8-B9E7-A635-2847020C42DA}"/>
+              </a:ext>
+            </a:extLst>
+          </p:cNvPr>
+          <p:cNvPicPr>
+            <a:picLocks noGrp="1" noChangeAspect="1"/>
+          </p:cNvPicPr>
+          <p:nvPr>
+            <p:ph idx="1"/>
+          </p:nvPr>
+        </p:nvPicPr>
+        <p:blipFill>
+          <a:blip r:embed="rId2" cstate="print">
+            <a:extLst>
+              <a:ext uri="{28A0092B-C50C-407E-A947-70E740481C1C}">
+                <a14:useLocalDpi xmlns:a14="http://schemas.microsoft.com/office/drawing/2010/main" val="0"/>
+              </a:ext>
+            </a:extLst>
+          </a:blip>
+          <a:stretch>
+            <a:fillRect/>
+          </a:stretch>
+        </p:blipFill>
+        <p:spPr>
+          <a:xfrm>
+            <a:off x="2114021" y="1268413"/>
+            <a:ext cx="7963958" cy="4778375"/>
+          </a:xfrm>
+        </p:spPr>
+      </p:pic>
       <p:sp>
         <p:nvSpPr>
-          <p:cNvPr id="6" name="Footer Placeholder 5">
+          <p:cNvPr id="3" name="Footer Placeholder 2">
             <a:extLst>
               <a:ext uri="{FF2B5EF4-FFF2-40B4-BE49-F238E27FC236}">
-                <a16:creationId xmlns:a16="http://schemas.microsoft.com/office/drawing/2014/main" id="{E3B7A61B-D8D4-25D7-9117-0E5D0CD15DA0}"/>
+                <a16:creationId xmlns:a16="http://schemas.microsoft.com/office/drawing/2014/main" id="{4D49CD3F-DDEB-35F0-1590-B4BEAB7342DB}"/>
               </a:ext>
             </a:extLst>
           </p:cNvPr>
@@ -4478,7 +4891,77 @@
             </a:pPr>
             <a:r>
               <a:rPr lang="en-US" altLang="ja-JP" dirty="0"/>
-              <a:t>Development of the Present Mechanism</a:t>
+              <a:t>Development of the Present Mech</a:t>
+            </a:r>
+          </a:p>
+        </p:txBody>
+      </p:sp>
+      <p:sp>
+        <p:nvSpPr>
+          <p:cNvPr id="4" name="Slide Number Placeholder 3">
+            <a:extLst>
+              <a:ext uri="{FF2B5EF4-FFF2-40B4-BE49-F238E27FC236}">
+                <a16:creationId xmlns:a16="http://schemas.microsoft.com/office/drawing/2014/main" id="{DF71506F-1891-8405-F7AF-B44D48DA9A2E}"/>
+              </a:ext>
+            </a:extLst>
+          </p:cNvPr>
+          <p:cNvSpPr>
+            <a:spLocks noGrp="1"/>
+          </p:cNvSpPr>
+          <p:nvPr>
+            <p:ph type="sldNum" sz="quarter" idx="11"/>
+          </p:nvPr>
+        </p:nvSpPr>
+        <p:spPr/>
+        <p:txBody>
+          <a:bodyPr/>
+          <a:lstStyle/>
+          <a:p>
+            <a:pPr>
+              <a:defRPr/>
+            </a:pPr>
+            <a:fld id="{F0030BFF-6758-4814-A89A-12C821A76488}" type="slidenum">
+              <a:rPr lang="en-US" altLang="ja-JP" smtClean="0"/>
+              <a:pPr>
+                <a:defRPr/>
+              </a:pPr>
+              <a:t>7</a:t>
+            </a:fld>
+            <a:endParaRPr lang="en-US" altLang="ja-JP"/>
+          </a:p>
+        </p:txBody>
+      </p:sp>
+      <p:sp>
+        <p:nvSpPr>
+          <p:cNvPr id="7" name="TextBox 6">
+            <a:extLst>
+              <a:ext uri="{FF2B5EF4-FFF2-40B4-BE49-F238E27FC236}">
+                <a16:creationId xmlns:a16="http://schemas.microsoft.com/office/drawing/2014/main" id="{DF5A53BA-7F1B-DA21-5845-6B18797F2D98}"/>
+              </a:ext>
+            </a:extLst>
+          </p:cNvPr>
+          <p:cNvSpPr txBox="1"/>
+          <p:nvPr/>
+        </p:nvSpPr>
+        <p:spPr>
+          <a:xfrm>
+            <a:off x="2135560" y="6021288"/>
+            <a:ext cx="7920880" cy="523220"/>
+          </a:xfrm>
+          <a:prstGeom prst="rect">
+            <a:avLst/>
+          </a:prstGeom>
+          <a:noFill/>
+        </p:spPr>
+        <p:txBody>
+          <a:bodyPr wrap="square" rtlCol="0">
+            <a:spAutoFit/>
+          </a:bodyPr>
+          <a:lstStyle/>
+          <a:p>
+            <a:r>
+              <a:rPr lang="en-US" sz="1400" dirty="0"/>
+              <a:t>Figure: Experimental and numerical laminar burning velocity of NH3/H2/air flames under stoichiometric condition at various hydrogen concentrations.</a:t>
             </a:r>
           </a:p>
         </p:txBody>
@@ -4486,7 +4969,278 @@
     </p:spTree>
     <p:extLst>
       <p:ext uri="{BB962C8B-B14F-4D97-AF65-F5344CB8AC3E}">
-        <p14:creationId xmlns:p14="http://schemas.microsoft.com/office/powerpoint/2010/main" val="4171800105"/>
+        <p14:creationId xmlns:p14="http://schemas.microsoft.com/office/powerpoint/2010/main" val="4216167048"/>
+      </p:ext>
+    </p:extLst>
+  </p:cSld>
+  <p:clrMapOvr>
+    <a:masterClrMapping/>
+  </p:clrMapOvr>
+</p:sld>
+</file>
+
+<file path=ppt/slides/slide9.xml><?xml version="1.0" encoding="utf-8"?>
+<p:sld xmlns:a="http://schemas.openxmlformats.org/drawingml/2006/main" xmlns:r="http://schemas.openxmlformats.org/officeDocument/2006/relationships" xmlns:p="http://schemas.openxmlformats.org/presentationml/2006/main">
+  <p:cSld>
+    <p:spTree>
+      <p:nvGrpSpPr>
+        <p:cNvPr id="1" name=""/>
+        <p:cNvGrpSpPr/>
+        <p:nvPr/>
+      </p:nvGrpSpPr>
+      <p:grpSpPr>
+        <a:xfrm>
+          <a:off x="0" y="0"/>
+          <a:ext cx="0" cy="0"/>
+          <a:chOff x="0" y="0"/>
+          <a:chExt cx="0" cy="0"/>
+        </a:xfrm>
+      </p:grpSpPr>
+      <p:pic>
+        <p:nvPicPr>
+          <p:cNvPr id="9" name="Content Placeholder 8">
+            <a:extLst>
+              <a:ext uri="{FF2B5EF4-FFF2-40B4-BE49-F238E27FC236}">
+                <a16:creationId xmlns:a16="http://schemas.microsoft.com/office/drawing/2014/main" id="{90D67F15-3E02-AC3D-E2FC-D73F68793F8C}"/>
+              </a:ext>
+            </a:extLst>
+          </p:cNvPr>
+          <p:cNvPicPr>
+            <a:picLocks noGrp="1" noChangeAspect="1"/>
+          </p:cNvPicPr>
+          <p:nvPr>
+            <p:ph idx="1"/>
+          </p:nvPr>
+        </p:nvPicPr>
+        <p:blipFill>
+          <a:blip r:embed="rId2" cstate="print">
+            <a:extLst>
+              <a:ext uri="{28A0092B-C50C-407E-A947-70E740481C1C}">
+                <a14:useLocalDpi xmlns:a14="http://schemas.microsoft.com/office/drawing/2010/main" val="0"/>
+              </a:ext>
+            </a:extLst>
+          </a:blip>
+          <a:stretch>
+            <a:fillRect/>
+          </a:stretch>
+        </p:blipFill>
+        <p:spPr>
+          <a:xfrm>
+            <a:off x="750407" y="1340768"/>
+            <a:ext cx="10691186" cy="4043485"/>
+          </a:xfrm>
+        </p:spPr>
+      </p:pic>
+      <p:sp>
+        <p:nvSpPr>
+          <p:cNvPr id="6" name="Footer Placeholder 5">
+            <a:extLst>
+              <a:ext uri="{FF2B5EF4-FFF2-40B4-BE49-F238E27FC236}">
+                <a16:creationId xmlns:a16="http://schemas.microsoft.com/office/drawing/2014/main" id="{DEB392FD-A7DC-53D3-86AA-59DB820A8B3D}"/>
+              </a:ext>
+            </a:extLst>
+          </p:cNvPr>
+          <p:cNvSpPr>
+            <a:spLocks noGrp="1"/>
+          </p:cNvSpPr>
+          <p:nvPr>
+            <p:ph type="ftr" sz="quarter" idx="10"/>
+          </p:nvPr>
+        </p:nvSpPr>
+        <p:spPr/>
+        <p:txBody>
+          <a:bodyPr/>
+          <a:lstStyle/>
+          <a:p>
+            <a:pPr algn="l">
+              <a:defRPr/>
+            </a:pPr>
+            <a:r>
+              <a:rPr lang="en-US" altLang="ja-JP" dirty="0"/>
+              <a:t>Development of the Present Mech</a:t>
+            </a:r>
+          </a:p>
+        </p:txBody>
+      </p:sp>
+      <p:sp>
+        <p:nvSpPr>
+          <p:cNvPr id="5" name="Slide Number Placeholder 4">
+            <a:extLst>
+              <a:ext uri="{FF2B5EF4-FFF2-40B4-BE49-F238E27FC236}">
+                <a16:creationId xmlns:a16="http://schemas.microsoft.com/office/drawing/2014/main" id="{1E9C4219-3EB0-B365-10B3-08342118FE65}"/>
+              </a:ext>
+            </a:extLst>
+          </p:cNvPr>
+          <p:cNvSpPr>
+            <a:spLocks noGrp="1"/>
+          </p:cNvSpPr>
+          <p:nvPr>
+            <p:ph type="sldNum" sz="quarter" idx="11"/>
+          </p:nvPr>
+        </p:nvSpPr>
+        <p:spPr/>
+        <p:txBody>
+          <a:bodyPr/>
+          <a:lstStyle/>
+          <a:p>
+            <a:pPr>
+              <a:defRPr/>
+            </a:pPr>
+            <a:fld id="{5E160AE0-185D-4321-8E65-BC536618BE04}" type="slidenum">
+              <a:rPr lang="en-US" altLang="ja-JP" smtClean="0"/>
+              <a:pPr>
+                <a:defRPr/>
+              </a:pPr>
+              <a:t>8</a:t>
+            </a:fld>
+            <a:endParaRPr lang="en-US" altLang="ja-JP"/>
+          </a:p>
+        </p:txBody>
+      </p:sp>
+      <mc:AlternateContent xmlns:mc="http://schemas.openxmlformats.org/markup-compatibility/2006">
+        <mc:Choice xmlns:a14="http://schemas.microsoft.com/office/drawing/2010/main" Requires="a14">
+          <p:sp>
+            <p:nvSpPr>
+              <p:cNvPr id="10" name="TextBox 9">
+                <a:extLst>
+                  <a:ext uri="{FF2B5EF4-FFF2-40B4-BE49-F238E27FC236}">
+                    <a16:creationId xmlns:a16="http://schemas.microsoft.com/office/drawing/2014/main" id="{1E12F815-FBBD-6F5C-6657-204ABE3DAB9A}"/>
+                  </a:ext>
+                </a:extLst>
+              </p:cNvPr>
+              <p:cNvSpPr txBox="1"/>
+              <p:nvPr/>
+            </p:nvSpPr>
+            <p:spPr>
+              <a:xfrm>
+                <a:off x="762000" y="5661248"/>
+                <a:ext cx="10662592" cy="907941"/>
+              </a:xfrm>
+              <a:prstGeom prst="rect">
+                <a:avLst/>
+              </a:prstGeom>
+              <a:noFill/>
+            </p:spPr>
+            <p:txBody>
+              <a:bodyPr wrap="square" rtlCol="0">
+                <a:spAutoFit/>
+              </a:bodyPr>
+              <a:lstStyle/>
+              <a:p>
+                <a:r>
+                  <a:rPr lang="en-US" sz="1600" dirty="0"/>
+                  <a:t>			(a)						(b)</a:t>
+                </a:r>
+              </a:p>
+              <a:p>
+                <a:endParaRPr lang="en-US" sz="900" dirty="0"/>
+              </a:p>
+              <a:p>
+                <a:r>
+                  <a:rPr lang="en-US" sz="1400" dirty="0"/>
+                  <a:t>Figure: Reaction pathway of NH3/H2/air flame at </a:t>
+                </a:r>
+                <a14:m>
+                  <m:oMath xmlns:m="http://schemas.openxmlformats.org/officeDocument/2006/math">
+                    <m:sSub>
+                      <m:sSubPr>
+                        <m:ctrlPr>
+                          <a:rPr lang="en-US" sz="1400" b="0" i="1" smtClean="0">
+                            <a:latin typeface="Cambria Math" panose="02040503050406030204" pitchFamily="18" charset="0"/>
+                          </a:rPr>
+                        </m:ctrlPr>
+                      </m:sSubPr>
+                      <m:e>
+                        <m:r>
+                          <a:rPr lang="en-US" sz="1400" b="0" i="1" smtClean="0">
+                            <a:latin typeface="Cambria Math" panose="02040503050406030204" pitchFamily="18" charset="0"/>
+                          </a:rPr>
+                          <m:t>𝑋</m:t>
+                        </m:r>
+                      </m:e>
+                      <m:sub>
+                        <m:r>
+                          <m:rPr>
+                            <m:sty m:val="p"/>
+                          </m:rPr>
+                          <a:rPr lang="en-US" sz="1400" b="0" i="0" smtClean="0">
+                            <a:latin typeface="Cambria Math" panose="02040503050406030204" pitchFamily="18" charset="0"/>
+                          </a:rPr>
+                          <m:t>H</m:t>
+                        </m:r>
+                        <m:r>
+                          <a:rPr lang="en-US" sz="1400" b="0" i="0" smtClean="0">
+                            <a:latin typeface="Cambria Math" panose="02040503050406030204" pitchFamily="18" charset="0"/>
+                          </a:rPr>
+                          <m:t>2</m:t>
+                        </m:r>
+                      </m:sub>
+                    </m:sSub>
+                    <m:r>
+                      <a:rPr lang="en-US" sz="1400" b="0" i="1" smtClean="0">
+                        <a:latin typeface="Cambria Math" panose="02040503050406030204" pitchFamily="18" charset="0"/>
+                      </a:rPr>
+                      <m:t>=0.5</m:t>
+                    </m:r>
+                  </m:oMath>
+                </a14:m>
+                <a:r>
+                  <a:rPr lang="en-US" sz="1400" dirty="0"/>
+                  <a:t> and equivalence ratio of 1.0 using (a) Okafor Reduced Mech and (b) Gotama Mech.</a:t>
+                </a:r>
+              </a:p>
+            </p:txBody>
+          </p:sp>
+        </mc:Choice>
+        <mc:Fallback>
+          <p:sp>
+            <p:nvSpPr>
+              <p:cNvPr id="10" name="TextBox 9">
+                <a:extLst>
+                  <a:ext uri="{FF2B5EF4-FFF2-40B4-BE49-F238E27FC236}">
+                    <a16:creationId xmlns:a16="http://schemas.microsoft.com/office/drawing/2014/main" id="{1E12F815-FBBD-6F5C-6657-204ABE3DAB9A}"/>
+                  </a:ext>
+                </a:extLst>
+              </p:cNvPr>
+              <p:cNvSpPr txBox="1">
+                <a:spLocks noRot="1" noChangeAspect="1" noMove="1" noResize="1" noEditPoints="1" noAdjustHandles="1" noChangeArrowheads="1" noChangeShapeType="1" noTextEdit="1"/>
+              </p:cNvSpPr>
+              <p:nvPr/>
+            </p:nvSpPr>
+            <p:spPr>
+              <a:xfrm>
+                <a:off x="762000" y="5661248"/>
+                <a:ext cx="10662592" cy="907941"/>
+              </a:xfrm>
+              <a:prstGeom prst="rect">
+                <a:avLst/>
+              </a:prstGeom>
+              <a:blipFill>
+                <a:blip r:embed="rId3"/>
+                <a:stretch>
+                  <a:fillRect l="-172" t="-2013" b="-6040"/>
+                </a:stretch>
+              </a:blipFill>
+            </p:spPr>
+            <p:txBody>
+              <a:bodyPr/>
+              <a:lstStyle/>
+              <a:p>
+                <a:r>
+                  <a:rPr lang="en-US">
+                    <a:noFill/>
+                  </a:rPr>
+                  <a:t> </a:t>
+                </a:r>
+              </a:p>
+            </p:txBody>
+          </p:sp>
+        </mc:Fallback>
+      </mc:AlternateContent>
+    </p:spTree>
+    <p:extLst>
+      <p:ext uri="{BB962C8B-B14F-4D97-AF65-F5344CB8AC3E}">
+        <p14:creationId xmlns:p14="http://schemas.microsoft.com/office/powerpoint/2010/main" val="1550952523"/>
       </p:ext>
     </p:extLst>
   </p:cSld>
@@ -6039,18 +6793,18 @@
 </file>
 
 <file path=customXml/item2.xml><?xml version="1.0" encoding="utf-8"?>
-<p:properties xmlns:p="http://schemas.microsoft.com/office/2006/metadata/properties" xmlns:xsi="http://www.w3.org/2001/XMLSchema-instance" xmlns:pc="http://schemas.microsoft.com/office/infopath/2007/PartnerControls">
-  <documentManagement/>
-</p:properties>
-</file>
-
-<file path=customXml/item3.xml><?xml version="1.0" encoding="utf-8"?>
 <?mso-contentType ?>
 <FormTemplates xmlns="http://schemas.microsoft.com/sharepoint/v3/contenttype/forms">
   <Display>DocumentLibraryForm</Display>
   <Edit>DocumentLibraryForm</Edit>
   <New>DocumentLibraryForm</New>
 </FormTemplates>
+</file>
+
+<file path=customXml/item3.xml><?xml version="1.0" encoding="utf-8"?>
+<p:properties xmlns:p="http://schemas.microsoft.com/office/2006/metadata/properties" xmlns:xsi="http://www.w3.org/2001/XMLSchema-instance" xmlns:pc="http://schemas.microsoft.com/office/infopath/2007/PartnerControls">
+  <documentManagement/>
+</p:properties>
 </file>
 
 <file path=customXml/itemProps1.xml><?xml version="1.0" encoding="utf-8"?>
@@ -6073,6 +6827,14 @@
 </file>
 
 <file path=customXml/itemProps2.xml><?xml version="1.0" encoding="utf-8"?>
+<ds:datastoreItem xmlns:ds="http://schemas.openxmlformats.org/officeDocument/2006/customXml" ds:itemID="{9C6B76C4-5C7C-488F-A583-DEEA7B62FA01}">
+  <ds:schemaRefs>
+    <ds:schemaRef ds:uri="http://schemas.microsoft.com/sharepoint/v3/contenttype/forms"/>
+  </ds:schemaRefs>
+</ds:datastoreItem>
+</file>
+
+<file path=customXml/itemProps3.xml><?xml version="1.0" encoding="utf-8"?>
 <ds:datastoreItem xmlns:ds="http://schemas.openxmlformats.org/officeDocument/2006/customXml" ds:itemID="{FD0DF8EC-7DE8-4F6C-8A29-3A49F665EFE3}">
   <ds:schemaRefs>
     <ds:schemaRef ds:uri="http://purl.org/dc/elements/1.1/"/>
@@ -6087,12 +6849,4 @@
     <ds:schemaRef ds:uri="http://schemas.microsoft.com/office/2006/metadata/properties"/>
   </ds:schemaRefs>
 </ds:datastoreItem>
-</file>
-
-<file path=customXml/itemProps3.xml><?xml version="1.0" encoding="utf-8"?>
-<ds:datastoreItem xmlns:ds="http://schemas.openxmlformats.org/officeDocument/2006/customXml" ds:itemID="{9C6B76C4-5C7C-488F-A583-DEEA7B62FA01}">
-  <ds:schemaRefs>
-    <ds:schemaRef ds:uri="http://schemas.microsoft.com/sharepoint/v3/contenttype/forms"/>
-  </ds:schemaRefs>
-</ds:datastoreItem>
 </file>
</xml_diff>

<commit_message>
made changes, removed redundant ppt
</commit_message>
<xml_diff>
--- a/icfd2026/pres/kyushu_ppt_16-9.pptx
+++ b/icfd2026/pres/kyushu_ppt_16-9.pptx
@@ -5,26 +5,25 @@
     <p:sldMasterId id="2147483648" r:id="rId4"/>
   </p:sldMasterIdLst>
   <p:notesMasterIdLst>
-    <p:notesMasterId r:id="rId19"/>
+    <p:notesMasterId r:id="rId18"/>
   </p:notesMasterIdLst>
   <p:handoutMasterIdLst>
-    <p:handoutMasterId r:id="rId20"/>
+    <p:handoutMasterId r:id="rId19"/>
   </p:handoutMasterIdLst>
   <p:sldIdLst>
     <p:sldId id="260" r:id="rId5"/>
     <p:sldId id="262" r:id="rId6"/>
     <p:sldId id="270" r:id="rId7"/>
     <p:sldId id="263" r:id="rId8"/>
-    <p:sldId id="268" r:id="rId9"/>
-    <p:sldId id="266" r:id="rId10"/>
-    <p:sldId id="271" r:id="rId11"/>
-    <p:sldId id="272" r:id="rId12"/>
-    <p:sldId id="274" r:id="rId13"/>
-    <p:sldId id="273" r:id="rId14"/>
-    <p:sldId id="275" r:id="rId15"/>
-    <p:sldId id="277" r:id="rId16"/>
-    <p:sldId id="279" r:id="rId17"/>
-    <p:sldId id="278" r:id="rId18"/>
+    <p:sldId id="266" r:id="rId9"/>
+    <p:sldId id="271" r:id="rId10"/>
+    <p:sldId id="272" r:id="rId11"/>
+    <p:sldId id="274" r:id="rId12"/>
+    <p:sldId id="273" r:id="rId13"/>
+    <p:sldId id="275" r:id="rId14"/>
+    <p:sldId id="277" r:id="rId15"/>
+    <p:sldId id="278" r:id="rId16"/>
+    <p:sldId id="280" r:id="rId17"/>
   </p:sldIdLst>
   <p:sldSz cx="12192000" cy="6858000"/>
   <p:notesSz cx="9144000" cy="6858000"/>
@@ -266,7 +265,7 @@
               <a:pPr>
                 <a:defRPr/>
               </a:pPr>
-              <a:t>2026/10/14</a:t>
+              <a:t>2026/10/15</a:t>
             </a:fld>
             <a:endParaRPr lang="ja-JP" altLang="en-US"/>
           </a:p>
@@ -1272,7 +1271,7 @@
               <a:pPr>
                 <a:defRPr/>
               </a:pPr>
-              <a:t>9</a:t>
+              <a:t>8</a:t>
             </a:fld>
             <a:endParaRPr lang="en-US" altLang="ja-JP"/>
           </a:p>
@@ -1377,7 +1376,7 @@
               <a:pPr>
                 <a:defRPr/>
               </a:pPr>
-              <a:t>10</a:t>
+              <a:t>9</a:t>
             </a:fld>
             <a:endParaRPr lang="en-US" altLang="ja-JP"/>
           </a:p>
@@ -1485,7 +1484,7 @@
               <a:pPr>
                 <a:defRPr/>
               </a:pPr>
-              <a:t>13</a:t>
+              <a:t>11</a:t>
             </a:fld>
             <a:endParaRPr lang="en-US" altLang="ja-JP"/>
           </a:p>
@@ -4068,358 +4067,8 @@
           <a:chExt cx="0" cy="0"/>
         </a:xfrm>
       </p:grpSpPr>
-      <p:pic>
-        <p:nvPicPr>
-          <p:cNvPr id="9" name="Content Placeholder 8">
-            <a:extLst>
-              <a:ext uri="{FF2B5EF4-FFF2-40B4-BE49-F238E27FC236}">
-                <a16:creationId xmlns:a16="http://schemas.microsoft.com/office/drawing/2014/main" id="{90D67F15-3E02-AC3D-E2FC-D73F68793F8C}"/>
-              </a:ext>
-            </a:extLst>
-          </p:cNvPr>
-          <p:cNvPicPr>
-            <a:picLocks noGrp="1" noChangeAspect="1"/>
-          </p:cNvPicPr>
-          <p:nvPr>
-            <p:ph idx="1"/>
-          </p:nvPr>
-        </p:nvPicPr>
-        <p:blipFill>
-          <a:blip r:embed="rId3" cstate="print">
-            <a:extLst>
-              <a:ext uri="{28A0092B-C50C-407E-A947-70E740481C1C}">
-                <a14:useLocalDpi xmlns:a14="http://schemas.microsoft.com/office/drawing/2010/main" val="0"/>
-              </a:ext>
-            </a:extLst>
-          </a:blip>
-          <a:stretch>
-            <a:fillRect/>
-          </a:stretch>
-        </p:blipFill>
-        <p:spPr>
-          <a:xfrm>
-            <a:off x="750407" y="1152907"/>
-            <a:ext cx="10691186" cy="4043485"/>
-          </a:xfrm>
-        </p:spPr>
-      </p:pic>
-      <p:sp>
-        <p:nvSpPr>
-          <p:cNvPr id="6" name="Footer Placeholder 5">
-            <a:extLst>
-              <a:ext uri="{FF2B5EF4-FFF2-40B4-BE49-F238E27FC236}">
-                <a16:creationId xmlns:a16="http://schemas.microsoft.com/office/drawing/2014/main" id="{DEB392FD-A7DC-53D3-86AA-59DB820A8B3D}"/>
-              </a:ext>
-            </a:extLst>
-          </p:cNvPr>
-          <p:cNvSpPr>
-            <a:spLocks noGrp="1"/>
-          </p:cNvSpPr>
-          <p:nvPr>
-            <p:ph type="ftr" sz="quarter" idx="4294967295"/>
-          </p:nvPr>
-        </p:nvSpPr>
-        <p:spPr>
-          <a:xfrm>
-            <a:off x="762000" y="260648"/>
-            <a:ext cx="10014520" cy="381000"/>
-          </a:xfrm>
-        </p:spPr>
-        <p:txBody>
-          <a:bodyPr/>
-          <a:lstStyle/>
-          <a:p>
-            <a:pPr algn="l">
-              <a:defRPr/>
-            </a:pPr>
-            <a:r>
-              <a:rPr lang="en-US" altLang="ja-JP" dirty="0"/>
-              <a:t>Development of the Present Mech</a:t>
-            </a:r>
-          </a:p>
-        </p:txBody>
-      </p:sp>
-      <p:sp>
-        <p:nvSpPr>
-          <p:cNvPr id="5" name="Slide Number Placeholder 4">
-            <a:extLst>
-              <a:ext uri="{FF2B5EF4-FFF2-40B4-BE49-F238E27FC236}">
-                <a16:creationId xmlns:a16="http://schemas.microsoft.com/office/drawing/2014/main" id="{1E9C4219-3EB0-B365-10B3-08342118FE65}"/>
-              </a:ext>
-            </a:extLst>
-          </p:cNvPr>
-          <p:cNvSpPr>
-            <a:spLocks noGrp="1"/>
-          </p:cNvSpPr>
-          <p:nvPr>
-            <p:ph type="sldNum" sz="quarter" idx="11"/>
-          </p:nvPr>
-        </p:nvSpPr>
-        <p:spPr/>
-        <p:txBody>
-          <a:bodyPr/>
-          <a:lstStyle/>
-          <a:p>
-            <a:pPr>
-              <a:defRPr/>
-            </a:pPr>
-            <a:fld id="{5E160AE0-185D-4321-8E65-BC536618BE04}" type="slidenum">
-              <a:rPr lang="en-US" altLang="ja-JP" smtClean="0"/>
-              <a:pPr>
-                <a:defRPr/>
-              </a:pPr>
-              <a:t>9</a:t>
-            </a:fld>
-            <a:endParaRPr lang="en-US" altLang="ja-JP"/>
-          </a:p>
-        </p:txBody>
-      </p:sp>
       <mc:AlternateContent xmlns:mc="http://schemas.openxmlformats.org/markup-compatibility/2006" xmlns:a14="http://schemas.microsoft.com/office/drawing/2010/main">
         <mc:Choice Requires="a14">
-          <p:sp>
-            <p:nvSpPr>
-              <p:cNvPr id="10" name="TextBox 9">
-                <a:extLst>
-                  <a:ext uri="{FF2B5EF4-FFF2-40B4-BE49-F238E27FC236}">
-                    <a16:creationId xmlns:a16="http://schemas.microsoft.com/office/drawing/2014/main" id="{1E12F815-FBBD-6F5C-6657-204ABE3DAB9A}"/>
-                  </a:ext>
-                </a:extLst>
-              </p:cNvPr>
-              <p:cNvSpPr txBox="1"/>
-              <p:nvPr/>
-            </p:nvSpPr>
-            <p:spPr>
-              <a:xfrm>
-                <a:off x="762000" y="5473387"/>
-                <a:ext cx="10662592" cy="907941"/>
-              </a:xfrm>
-              <a:prstGeom prst="rect">
-                <a:avLst/>
-              </a:prstGeom>
-              <a:noFill/>
-            </p:spPr>
-            <p:txBody>
-              <a:bodyPr wrap="square" rtlCol="0">
-                <a:spAutoFit/>
-              </a:bodyPr>
-              <a:lstStyle/>
-              <a:p>
-                <a:r>
-                  <a:rPr lang="en-US" sz="1600" dirty="0"/>
-                  <a:t>			(a)						(b)</a:t>
-                </a:r>
-              </a:p>
-              <a:p>
-                <a:endParaRPr lang="en-US" sz="900" dirty="0"/>
-              </a:p>
-              <a:p>
-                <a:r>
-                  <a:rPr lang="en-US" sz="1400" dirty="0"/>
-                  <a:t>Figure: Reaction pathway of NH3/H2/air flame at </a:t>
-                </a:r>
-                <a14:m>
-                  <m:oMath xmlns:m="http://schemas.openxmlformats.org/officeDocument/2006/math">
-                    <m:sSub>
-                      <m:sSubPr>
-                        <m:ctrlPr>
-                          <a:rPr lang="en-US" sz="1400" b="0" i="1" smtClean="0">
-                            <a:latin typeface="Cambria Math" panose="02040503050406030204" pitchFamily="18" charset="0"/>
-                          </a:rPr>
-                        </m:ctrlPr>
-                      </m:sSubPr>
-                      <m:e>
-                        <m:r>
-                          <a:rPr lang="en-US" sz="1400" b="0" i="1" smtClean="0">
-                            <a:latin typeface="Cambria Math" panose="02040503050406030204" pitchFamily="18" charset="0"/>
-                          </a:rPr>
-                          <m:t>𝑋</m:t>
-                        </m:r>
-                      </m:e>
-                      <m:sub>
-                        <m:r>
-                          <m:rPr>
-                            <m:sty m:val="p"/>
-                          </m:rPr>
-                          <a:rPr lang="en-US" sz="1400" b="0" i="0" smtClean="0">
-                            <a:latin typeface="Cambria Math" panose="02040503050406030204" pitchFamily="18" charset="0"/>
-                          </a:rPr>
-                          <m:t>H</m:t>
-                        </m:r>
-                        <m:r>
-                          <a:rPr lang="en-US" sz="1400" b="0" i="0" smtClean="0">
-                            <a:latin typeface="Cambria Math" panose="02040503050406030204" pitchFamily="18" charset="0"/>
-                          </a:rPr>
-                          <m:t>2</m:t>
-                        </m:r>
-                      </m:sub>
-                    </m:sSub>
-                    <m:r>
-                      <a:rPr lang="en-US" sz="1400" b="0" i="1" smtClean="0">
-                        <a:latin typeface="Cambria Math" panose="02040503050406030204" pitchFamily="18" charset="0"/>
-                      </a:rPr>
-                      <m:t>=0.5</m:t>
-                    </m:r>
-                  </m:oMath>
-                </a14:m>
-                <a:r>
-                  <a:rPr lang="en-US" sz="1400" dirty="0"/>
-                  <a:t> and equivalence ratio of 1.0 using (a) Okafor Reduced Mech and (b) Gotama Mech.</a:t>
-                </a:r>
-              </a:p>
-            </p:txBody>
-          </p:sp>
-        </mc:Choice>
-        <mc:Fallback xmlns="">
-          <p:sp>
-            <p:nvSpPr>
-              <p:cNvPr id="10" name="TextBox 9">
-                <a:extLst>
-                  <a:ext uri="{FF2B5EF4-FFF2-40B4-BE49-F238E27FC236}">
-                    <a16:creationId xmlns:a16="http://schemas.microsoft.com/office/drawing/2014/main" id="{1E12F815-FBBD-6F5C-6657-204ABE3DAB9A}"/>
-                  </a:ext>
-                </a:extLst>
-              </p:cNvPr>
-              <p:cNvSpPr txBox="1">
-                <a:spLocks noRot="1" noChangeAspect="1" noMove="1" noResize="1" noEditPoints="1" noAdjustHandles="1" noChangeArrowheads="1" noChangeShapeType="1" noTextEdit="1"/>
-              </p:cNvSpPr>
-              <p:nvPr/>
-            </p:nvSpPr>
-            <p:spPr>
-              <a:xfrm>
-                <a:off x="762000" y="5473387"/>
-                <a:ext cx="10662592" cy="907941"/>
-              </a:xfrm>
-              <a:prstGeom prst="rect">
-                <a:avLst/>
-              </a:prstGeom>
-              <a:blipFill>
-                <a:blip r:embed="rId4"/>
-                <a:stretch>
-                  <a:fillRect l="-172" t="-2013" b="-6040"/>
-                </a:stretch>
-              </a:blipFill>
-            </p:spPr>
-            <p:txBody>
-              <a:bodyPr/>
-              <a:lstStyle/>
-              <a:p>
-                <a:r>
-                  <a:rPr lang="en-US">
-                    <a:noFill/>
-                  </a:rPr>
-                  <a:t> </a:t>
-                </a:r>
-              </a:p>
-            </p:txBody>
-          </p:sp>
-        </mc:Fallback>
-      </mc:AlternateContent>
-      <p:sp>
-        <p:nvSpPr>
-          <p:cNvPr id="11" name="TextBox 10">
-            <a:extLst>
-              <a:ext uri="{FF2B5EF4-FFF2-40B4-BE49-F238E27FC236}">
-                <a16:creationId xmlns:a16="http://schemas.microsoft.com/office/drawing/2014/main" id="{FC4FD694-35C0-7260-D6C0-0D6F732C40DC}"/>
-              </a:ext>
-            </a:extLst>
-          </p:cNvPr>
-          <p:cNvSpPr txBox="1"/>
-          <p:nvPr/>
-        </p:nvSpPr>
-        <p:spPr>
-          <a:xfrm>
-            <a:off x="2927648" y="4579992"/>
-            <a:ext cx="576064" cy="107722"/>
-          </a:xfrm>
-          <a:prstGeom prst="rect">
-            <a:avLst/>
-          </a:prstGeom>
-          <a:solidFill>
-            <a:schemeClr val="bg1"/>
-          </a:solidFill>
-        </p:spPr>
-        <p:txBody>
-          <a:bodyPr wrap="square" lIns="0" tIns="0" rIns="0" bIns="0" rtlCol="0">
-            <a:spAutoFit/>
-          </a:bodyPr>
-          <a:lstStyle/>
-          <a:p>
-            <a:r>
-              <a:rPr lang="en-US" sz="700" dirty="0"/>
-              <a:t>Unimolecular</a:t>
-            </a:r>
-          </a:p>
-        </p:txBody>
-      </p:sp>
-      <p:sp>
-        <p:nvSpPr>
-          <p:cNvPr id="13" name="TextBox 12">
-            <a:extLst>
-              <a:ext uri="{FF2B5EF4-FFF2-40B4-BE49-F238E27FC236}">
-                <a16:creationId xmlns:a16="http://schemas.microsoft.com/office/drawing/2014/main" id="{BD85B8B6-BF69-9E8C-1E1C-1C7179046A5E}"/>
-              </a:ext>
-            </a:extLst>
-          </p:cNvPr>
-          <p:cNvSpPr txBox="1"/>
-          <p:nvPr/>
-        </p:nvSpPr>
-        <p:spPr>
-          <a:xfrm>
-            <a:off x="8293608" y="4096512"/>
-            <a:ext cx="576064" cy="107722"/>
-          </a:xfrm>
-          <a:prstGeom prst="rect">
-            <a:avLst/>
-          </a:prstGeom>
-          <a:solidFill>
-            <a:schemeClr val="bg1"/>
-          </a:solidFill>
-        </p:spPr>
-        <p:txBody>
-          <a:bodyPr wrap="square" lIns="0" tIns="0" rIns="0" bIns="0" rtlCol="0">
-            <a:spAutoFit/>
-          </a:bodyPr>
-          <a:lstStyle/>
-          <a:p>
-            <a:r>
-              <a:rPr lang="en-US" sz="700" dirty="0"/>
-              <a:t>Unimolecular</a:t>
-            </a:r>
-          </a:p>
-        </p:txBody>
-      </p:sp>
-    </p:spTree>
-    <p:extLst>
-      <p:ext uri="{BB962C8B-B14F-4D97-AF65-F5344CB8AC3E}">
-        <p14:creationId xmlns:p14="http://schemas.microsoft.com/office/powerpoint/2010/main" val="1550952523"/>
-      </p:ext>
-    </p:extLst>
-  </p:cSld>
-  <p:clrMapOvr>
-    <a:masterClrMapping/>
-  </p:clrMapOvr>
-</p:sld>
-</file>
-
-<file path=ppt/slides/slide11.xml><?xml version="1.0" encoding="utf-8"?>
-<p:sld xmlns:a="http://schemas.openxmlformats.org/drawingml/2006/main" xmlns:r="http://schemas.openxmlformats.org/officeDocument/2006/relationships" xmlns:p="http://schemas.openxmlformats.org/presentationml/2006/main">
-  <p:cSld>
-    <p:spTree>
-      <p:nvGrpSpPr>
-        <p:cNvPr id="1" name=""/>
-        <p:cNvGrpSpPr/>
-        <p:nvPr/>
-      </p:nvGrpSpPr>
-      <p:grpSpPr>
-        <a:xfrm>
-          <a:off x="0" y="0"/>
-          <a:ext cx="0" cy="0"/>
-          <a:chOff x="0" y="0"/>
-          <a:chExt cx="0" cy="0"/>
-        </a:xfrm>
-      </p:grpSpPr>
-      <mc:AlternateContent xmlns:mc="http://schemas.openxmlformats.org/markup-compatibility/2006">
-        <mc:Choice xmlns:a14="http://schemas.microsoft.com/office/drawing/2010/main" Requires="a14">
           <p:sp>
             <p:nvSpPr>
               <p:cNvPr id="2" name="Content Placeholder 1">
@@ -4581,7 +4230,7 @@
             </p:txBody>
           </p:sp>
         </mc:Choice>
-        <mc:Fallback>
+        <mc:Fallback xmlns="">
           <p:sp>
             <p:nvSpPr>
               <p:cNvPr id="2" name="Content Placeholder 1">
@@ -4686,7 +4335,7 @@
               <a:pPr>
                 <a:defRPr/>
               </a:pPr>
-              <a:t>10</a:t>
+              <a:t>9</a:t>
             </a:fld>
             <a:endParaRPr lang="en-US" altLang="ja-JP"/>
           </a:p>
@@ -4705,7 +4354,7 @@
 </p:sld>
 </file>
 
-<file path=ppt/slides/slide12.xml><?xml version="1.0" encoding="utf-8"?>
+<file path=ppt/slides/slide11.xml><?xml version="1.0" encoding="utf-8"?>
 <p:sld xmlns:a="http://schemas.openxmlformats.org/drawingml/2006/main" xmlns:r="http://schemas.openxmlformats.org/officeDocument/2006/relationships" xmlns:p="http://schemas.openxmlformats.org/presentationml/2006/main">
   <p:cSld>
     <p:spTree>
@@ -4821,7 +4470,7 @@
               <a:pPr>
                 <a:defRPr/>
               </a:pPr>
-              <a:t>11</a:t>
+              <a:t>10</a:t>
             </a:fld>
             <a:endParaRPr lang="en-US" altLang="ja-JP"/>
           </a:p>
@@ -4875,221 +4524,7 @@
 </p:sld>
 </file>
 
-<file path=ppt/slides/slide13.xml><?xml version="1.0" encoding="utf-8"?>
-<p:sld xmlns:a="http://schemas.openxmlformats.org/drawingml/2006/main" xmlns:r="http://schemas.openxmlformats.org/officeDocument/2006/relationships" xmlns:p="http://schemas.openxmlformats.org/presentationml/2006/main">
-  <p:cSld>
-    <p:spTree>
-      <p:nvGrpSpPr>
-        <p:cNvPr id="1" name=""/>
-        <p:cNvGrpSpPr/>
-        <p:nvPr/>
-      </p:nvGrpSpPr>
-      <p:grpSpPr>
-        <a:xfrm>
-          <a:off x="0" y="0"/>
-          <a:ext cx="0" cy="0"/>
-          <a:chOff x="0" y="0"/>
-          <a:chExt cx="0" cy="0"/>
-        </a:xfrm>
-      </p:grpSpPr>
-      <p:sp>
-        <p:nvSpPr>
-          <p:cNvPr id="5" name="Title 4">
-            <a:extLst>
-              <a:ext uri="{FF2B5EF4-FFF2-40B4-BE49-F238E27FC236}">
-                <a16:creationId xmlns:a16="http://schemas.microsoft.com/office/drawing/2014/main" id="{DECE77BF-120C-0DF1-341F-3065550CB74F}"/>
-              </a:ext>
-            </a:extLst>
-          </p:cNvPr>
-          <p:cNvSpPr>
-            <a:spLocks noGrp="1"/>
-          </p:cNvSpPr>
-          <p:nvPr>
-            <p:ph type="title"/>
-          </p:nvPr>
-        </p:nvSpPr>
-        <p:spPr/>
-        <p:txBody>
-          <a:bodyPr/>
-          <a:lstStyle/>
-          <a:p>
-            <a:r>
-              <a:rPr lang="en-US" altLang="ja-JP" dirty="0"/>
-              <a:t>Validation – NH3/CH4/air</a:t>
-            </a:r>
-            <a:endParaRPr lang="en-US" dirty="0"/>
-          </a:p>
-        </p:txBody>
-      </p:sp>
-      <p:pic>
-        <p:nvPicPr>
-          <p:cNvPr id="11" name="Content Placeholder 10">
-            <a:extLst>
-              <a:ext uri="{FF2B5EF4-FFF2-40B4-BE49-F238E27FC236}">
-                <a16:creationId xmlns:a16="http://schemas.microsoft.com/office/drawing/2014/main" id="{154B4EF3-E789-5CF8-F0E9-8984656812B7}"/>
-              </a:ext>
-            </a:extLst>
-          </p:cNvPr>
-          <p:cNvPicPr>
-            <a:picLocks noGrp="1" noChangeAspect="1"/>
-          </p:cNvPicPr>
-          <p:nvPr>
-            <p:ph sz="half" idx="1"/>
-          </p:nvPr>
-        </p:nvPicPr>
-        <p:blipFill>
-          <a:blip r:embed="rId2" cstate="print">
-            <a:extLst>
-              <a:ext uri="{28A0092B-C50C-407E-A947-70E740481C1C}">
-                <a14:useLocalDpi xmlns:a14="http://schemas.microsoft.com/office/drawing/2010/main" val="0"/>
-              </a:ext>
-            </a:extLst>
-          </a:blip>
-          <a:stretch>
-            <a:fillRect/>
-          </a:stretch>
-        </p:blipFill>
-        <p:spPr>
-          <a:xfrm>
-            <a:off x="479425" y="1824673"/>
-            <a:ext cx="5400675" cy="3240405"/>
-          </a:xfrm>
-        </p:spPr>
-      </p:pic>
-      <p:sp>
-        <p:nvSpPr>
-          <p:cNvPr id="7" name="Content Placeholder 6">
-            <a:extLst>
-              <a:ext uri="{FF2B5EF4-FFF2-40B4-BE49-F238E27FC236}">
-                <a16:creationId xmlns:a16="http://schemas.microsoft.com/office/drawing/2014/main" id="{EFE10B38-1C5E-4BAE-962E-588B7B79062F}"/>
-              </a:ext>
-            </a:extLst>
-          </p:cNvPr>
-          <p:cNvSpPr>
-            <a:spLocks noGrp="1"/>
-          </p:cNvSpPr>
-          <p:nvPr>
-            <p:ph sz="half" idx="2"/>
-          </p:nvPr>
-        </p:nvSpPr>
-        <p:spPr/>
-        <p:txBody>
-          <a:bodyPr/>
-          <a:lstStyle/>
-          <a:p>
-            <a:endParaRPr lang="en-US"/>
-          </a:p>
-        </p:txBody>
-      </p:sp>
-      <p:sp>
-        <p:nvSpPr>
-          <p:cNvPr id="4" name="Slide Number Placeholder 3">
-            <a:extLst>
-              <a:ext uri="{FF2B5EF4-FFF2-40B4-BE49-F238E27FC236}">
-                <a16:creationId xmlns:a16="http://schemas.microsoft.com/office/drawing/2014/main" id="{A7975842-4649-F3E2-CB5E-241ECEF3A168}"/>
-              </a:ext>
-            </a:extLst>
-          </p:cNvPr>
-          <p:cNvSpPr>
-            <a:spLocks noGrp="1"/>
-          </p:cNvSpPr>
-          <p:nvPr>
-            <p:ph type="sldNum" sz="quarter" idx="11"/>
-          </p:nvPr>
-        </p:nvSpPr>
-        <p:spPr/>
-        <p:txBody>
-          <a:bodyPr/>
-          <a:lstStyle/>
-          <a:p>
-            <a:pPr>
-              <a:defRPr/>
-            </a:pPr>
-            <a:fld id="{F0030BFF-6758-4814-A89A-12C821A76488}" type="slidenum">
-              <a:rPr lang="en-US" altLang="ja-JP" smtClean="0"/>
-              <a:pPr>
-                <a:defRPr/>
-              </a:pPr>
-              <a:t>12</a:t>
-            </a:fld>
-            <a:endParaRPr lang="en-US" altLang="ja-JP"/>
-          </a:p>
-        </p:txBody>
-      </p:sp>
-      <p:sp>
-        <p:nvSpPr>
-          <p:cNvPr id="8" name="Text Placeholder 7">
-            <a:extLst>
-              <a:ext uri="{FF2B5EF4-FFF2-40B4-BE49-F238E27FC236}">
-                <a16:creationId xmlns:a16="http://schemas.microsoft.com/office/drawing/2014/main" id="{9CCCB7E4-8F45-518D-04DA-3A1C5A9A0136}"/>
-              </a:ext>
-            </a:extLst>
-          </p:cNvPr>
-          <p:cNvSpPr>
-            <a:spLocks noGrp="1"/>
-          </p:cNvSpPr>
-          <p:nvPr>
-            <p:ph type="body" sz="quarter" idx="12"/>
-          </p:nvPr>
-        </p:nvSpPr>
-        <p:spPr/>
-        <p:txBody>
-          <a:bodyPr/>
-          <a:lstStyle/>
-          <a:p>
-            <a:endParaRPr lang="en-US"/>
-          </a:p>
-        </p:txBody>
-      </p:sp>
-      <p:sp>
-        <p:nvSpPr>
-          <p:cNvPr id="12" name="TextBox 11">
-            <a:extLst>
-              <a:ext uri="{FF2B5EF4-FFF2-40B4-BE49-F238E27FC236}">
-                <a16:creationId xmlns:a16="http://schemas.microsoft.com/office/drawing/2014/main" id="{AF0DA04E-0E1F-3C89-9C73-0799D4D9AFD4}"/>
-              </a:ext>
-            </a:extLst>
-          </p:cNvPr>
-          <p:cNvSpPr txBox="1"/>
-          <p:nvPr/>
-        </p:nvSpPr>
-        <p:spPr>
-          <a:xfrm>
-            <a:off x="479425" y="5414355"/>
-            <a:ext cx="5400675" cy="738664"/>
-          </a:xfrm>
-          <a:prstGeom prst="rect">
-            <a:avLst/>
-          </a:prstGeom>
-          <a:noFill/>
-        </p:spPr>
-        <p:txBody>
-          <a:bodyPr wrap="square" rtlCol="0">
-            <a:spAutoFit/>
-          </a:bodyPr>
-          <a:lstStyle/>
-          <a:p>
-            <a:r>
-              <a:rPr lang="en-US" sz="1400" dirty="0"/>
-              <a:t>Figure: Comparison of measured and simulated laminar burning velocity of NH3/CH4/air flames under stoichiometric condition and 1 atm of pressure.</a:t>
-            </a:r>
-          </a:p>
-        </p:txBody>
-      </p:sp>
-    </p:spTree>
-    <p:extLst>
-      <p:ext uri="{BB962C8B-B14F-4D97-AF65-F5344CB8AC3E}">
-        <p14:creationId xmlns:p14="http://schemas.microsoft.com/office/powerpoint/2010/main" val="3049752816"/>
-      </p:ext>
-    </p:extLst>
-  </p:cSld>
-  <p:clrMapOvr>
-    <a:masterClrMapping/>
-  </p:clrMapOvr>
-</p:sld>
-</file>
-
-<file path=ppt/slides/slide14.xml><?xml version="1.0" encoding="utf-8"?>
+<file path=ppt/slides/slide12.xml><?xml version="1.0" encoding="utf-8"?>
 <p:sld xmlns:a="http://schemas.openxmlformats.org/drawingml/2006/main" xmlns:r="http://schemas.openxmlformats.org/officeDocument/2006/relationships" xmlns:p="http://schemas.openxmlformats.org/presentationml/2006/main">
   <p:cSld>
     <p:spTree>
@@ -5159,9 +4594,8 @@
               </a:ext>
             </a:extLst>
           </a:blip>
-          <a:stretch>
-            <a:fillRect/>
-          </a:stretch>
+          <a:srcRect/>
+          <a:stretch/>
         </p:blipFill>
         <p:spPr>
           <a:xfrm>
@@ -5194,9 +4628,8 @@
               </a:ext>
             </a:extLst>
           </a:blip>
-          <a:stretch>
-            <a:fillRect/>
-          </a:stretch>
+          <a:srcRect/>
+          <a:stretch/>
         </p:blipFill>
         <p:spPr>
           <a:xfrm>
@@ -5234,14 +4667,14 @@
               <a:pPr>
                 <a:defRPr/>
               </a:pPr>
-              <a:t>13</a:t>
+              <a:t>11</a:t>
             </a:fld>
             <a:endParaRPr lang="en-US" altLang="ja-JP"/>
           </a:p>
         </p:txBody>
       </p:sp>
-      <mc:AlternateContent xmlns:mc="http://schemas.openxmlformats.org/markup-compatibility/2006">
-        <mc:Choice xmlns:a14="http://schemas.microsoft.com/office/drawing/2010/main" Requires="a14">
+      <mc:AlternateContent xmlns:mc="http://schemas.openxmlformats.org/markup-compatibility/2006" xmlns:a14="http://schemas.microsoft.com/office/drawing/2010/main">
+        <mc:Choice Requires="a14">
           <p:sp>
             <p:nvSpPr>
               <p:cNvPr id="18" name="TextBox 17">
@@ -5309,7 +4742,7 @@
             </p:txBody>
           </p:sp>
         </mc:Choice>
-        <mc:Fallback>
+        <mc:Fallback xmlns="">
           <p:sp>
             <p:nvSpPr>
               <p:cNvPr id="18" name="TextBox 17">
@@ -5354,8 +4787,8 @@
           </p:sp>
         </mc:Fallback>
       </mc:AlternateContent>
-      <mc:AlternateContent xmlns:mc="http://schemas.openxmlformats.org/markup-compatibility/2006">
-        <mc:Choice xmlns:a14="http://schemas.microsoft.com/office/drawing/2010/main" Requires="a14">
+      <mc:AlternateContent xmlns:mc="http://schemas.openxmlformats.org/markup-compatibility/2006" xmlns:a14="http://schemas.microsoft.com/office/drawing/2010/main">
+        <mc:Choice Requires="a14">
           <p:sp>
             <p:nvSpPr>
               <p:cNvPr id="20" name="TextBox 19">
@@ -5423,7 +4856,7 @@
             </p:txBody>
           </p:sp>
         </mc:Choice>
-        <mc:Fallback>
+        <mc:Fallback xmlns="">
           <p:sp>
             <p:nvSpPr>
               <p:cNvPr id="20" name="TextBox 19">
@@ -5481,6 +4914,169 @@
 </p:sld>
 </file>
 
+<file path=ppt/slides/slide13.xml><?xml version="1.0" encoding="utf-8"?>
+<p:sld xmlns:a="http://schemas.openxmlformats.org/drawingml/2006/main" xmlns:r="http://schemas.openxmlformats.org/officeDocument/2006/relationships" xmlns:p="http://schemas.openxmlformats.org/presentationml/2006/main">
+  <p:cSld>
+    <p:spTree>
+      <p:nvGrpSpPr>
+        <p:cNvPr id="1" name=""/>
+        <p:cNvGrpSpPr/>
+        <p:nvPr/>
+      </p:nvGrpSpPr>
+      <p:grpSpPr>
+        <a:xfrm>
+          <a:off x="0" y="0"/>
+          <a:ext cx="0" cy="0"/>
+          <a:chOff x="0" y="0"/>
+          <a:chExt cx="0" cy="0"/>
+        </a:xfrm>
+      </p:grpSpPr>
+      <p:sp>
+        <p:nvSpPr>
+          <p:cNvPr id="8" name="Title 7">
+            <a:extLst>
+              <a:ext uri="{FF2B5EF4-FFF2-40B4-BE49-F238E27FC236}">
+                <a16:creationId xmlns:a16="http://schemas.microsoft.com/office/drawing/2014/main" id="{169D1A46-5D8F-4403-6081-82DF5F8FD492}"/>
+              </a:ext>
+            </a:extLst>
+          </p:cNvPr>
+          <p:cNvSpPr>
+            <a:spLocks noGrp="1"/>
+          </p:cNvSpPr>
+          <p:nvPr>
+            <p:ph type="title"/>
+          </p:nvPr>
+        </p:nvSpPr>
+        <p:spPr/>
+        <p:txBody>
+          <a:bodyPr/>
+          <a:lstStyle/>
+          <a:p>
+            <a:r>
+              <a:rPr lang="en-US" dirty="0"/>
+              <a:t>Validation – NH3/CH4/air</a:t>
+            </a:r>
+          </a:p>
+        </p:txBody>
+      </p:sp>
+      <p:pic>
+        <p:nvPicPr>
+          <p:cNvPr id="11" name="Content Placeholder 10">
+            <a:extLst>
+              <a:ext uri="{FF2B5EF4-FFF2-40B4-BE49-F238E27FC236}">
+                <a16:creationId xmlns:a16="http://schemas.microsoft.com/office/drawing/2014/main" id="{DB58D9ED-C762-5FD5-631A-D67C968D3107}"/>
+              </a:ext>
+            </a:extLst>
+          </p:cNvPr>
+          <p:cNvPicPr>
+            <a:picLocks noGrp="1" noChangeAspect="1"/>
+          </p:cNvPicPr>
+          <p:nvPr>
+            <p:ph idx="1"/>
+          </p:nvPr>
+        </p:nvPicPr>
+        <p:blipFill>
+          <a:blip r:embed="rId2" cstate="print">
+            <a:extLst>
+              <a:ext uri="{28A0092B-C50C-407E-A947-70E740481C1C}">
+                <a14:useLocalDpi xmlns:a14="http://schemas.microsoft.com/office/drawing/2010/main" val="0"/>
+              </a:ext>
+            </a:extLst>
+          </a:blip>
+          <a:stretch>
+            <a:fillRect/>
+          </a:stretch>
+        </p:blipFill>
+        <p:spPr>
+          <a:xfrm>
+            <a:off x="2114021" y="1124744"/>
+            <a:ext cx="7963958" cy="4778375"/>
+          </a:xfrm>
+        </p:spPr>
+      </p:pic>
+      <p:sp>
+        <p:nvSpPr>
+          <p:cNvPr id="5" name="Slide Number Placeholder 4">
+            <a:extLst>
+              <a:ext uri="{FF2B5EF4-FFF2-40B4-BE49-F238E27FC236}">
+                <a16:creationId xmlns:a16="http://schemas.microsoft.com/office/drawing/2014/main" id="{5AFE24B0-4DD2-FEDE-6BF8-ADE28B4F2D11}"/>
+              </a:ext>
+            </a:extLst>
+          </p:cNvPr>
+          <p:cNvSpPr>
+            <a:spLocks noGrp="1"/>
+          </p:cNvSpPr>
+          <p:nvPr>
+            <p:ph type="sldNum" sz="quarter" idx="11"/>
+          </p:nvPr>
+        </p:nvSpPr>
+        <p:spPr/>
+        <p:txBody>
+          <a:bodyPr/>
+          <a:lstStyle/>
+          <a:p>
+            <a:pPr>
+              <a:defRPr/>
+            </a:pPr>
+            <a:fld id="{5E160AE0-185D-4321-8E65-BC536618BE04}" type="slidenum">
+              <a:rPr lang="en-US" altLang="ja-JP" smtClean="0"/>
+              <a:pPr>
+                <a:defRPr/>
+              </a:pPr>
+              <a:t>12</a:t>
+            </a:fld>
+            <a:endParaRPr lang="en-US" altLang="ja-JP"/>
+          </a:p>
+        </p:txBody>
+      </p:sp>
+      <p:sp>
+        <p:nvSpPr>
+          <p:cNvPr id="13" name="TextBox 12">
+            <a:extLst>
+              <a:ext uri="{FF2B5EF4-FFF2-40B4-BE49-F238E27FC236}">
+                <a16:creationId xmlns:a16="http://schemas.microsoft.com/office/drawing/2014/main" id="{F1BE4723-FD51-D863-6173-13FC2AB25BF7}"/>
+              </a:ext>
+            </a:extLst>
+          </p:cNvPr>
+          <p:cNvSpPr txBox="1"/>
+          <p:nvPr/>
+        </p:nvSpPr>
+        <p:spPr>
+          <a:xfrm>
+            <a:off x="2114021" y="5858108"/>
+            <a:ext cx="7963958" cy="523220"/>
+          </a:xfrm>
+          <a:prstGeom prst="rect">
+            <a:avLst/>
+          </a:prstGeom>
+          <a:noFill/>
+        </p:spPr>
+        <p:txBody>
+          <a:bodyPr wrap="square" rtlCol="0">
+            <a:spAutoFit/>
+          </a:bodyPr>
+          <a:lstStyle/>
+          <a:p>
+            <a:r>
+              <a:rPr lang="en-US" sz="1400" dirty="0"/>
+              <a:t>Figure: Comparison of measured and simulated laminar burning velocity of NH3/CH4/air flames under stoichiometric condition and 1 atm of pressure.</a:t>
+            </a:r>
+          </a:p>
+        </p:txBody>
+      </p:sp>
+    </p:spTree>
+    <p:extLst>
+      <p:ext uri="{BB962C8B-B14F-4D97-AF65-F5344CB8AC3E}">
+        <p14:creationId xmlns:p14="http://schemas.microsoft.com/office/powerpoint/2010/main" val="3886026801"/>
+      </p:ext>
+    </p:extLst>
+  </p:cSld>
+  <p:clrMapOvr>
+    <a:masterClrMapping/>
+  </p:clrMapOvr>
+</p:sld>
+</file>
+
 <file path=ppt/slides/slide2.xml><?xml version="1.0" encoding="utf-8"?>
 <p:sld xmlns:a="http://schemas.openxmlformats.org/drawingml/2006/main" xmlns:r="http://schemas.openxmlformats.org/officeDocument/2006/relationships" xmlns:p="http://schemas.openxmlformats.org/presentationml/2006/main">
   <p:cSld>
@@ -5642,140 +5238,40 @@
           <a:chExt cx="0" cy="0"/>
         </a:xfrm>
       </p:grpSpPr>
-      <mc:AlternateContent xmlns:mc="http://schemas.openxmlformats.org/markup-compatibility/2006" xmlns:a14="http://schemas.microsoft.com/office/drawing/2010/main">
-        <mc:Choice Requires="a14">
-          <p:sp>
-            <p:nvSpPr>
-              <p:cNvPr id="2" name="Content Placeholder 1">
-                <a:extLst>
-                  <a:ext uri="{FF2B5EF4-FFF2-40B4-BE49-F238E27FC236}">
-                    <a16:creationId xmlns:a16="http://schemas.microsoft.com/office/drawing/2014/main" id="{CBBCF3C5-C505-2F53-DE0B-D375D6591BD1}"/>
-                  </a:ext>
-                </a:extLst>
-              </p:cNvPr>
-              <p:cNvSpPr>
-                <a:spLocks noGrp="1"/>
-              </p:cNvSpPr>
-              <p:nvPr>
-                <p:ph idx="1"/>
-              </p:nvPr>
-            </p:nvSpPr>
-            <p:spPr/>
-            <p:txBody>
-              <a:bodyPr/>
-              <a:lstStyle/>
-              <a:p>
-                <a:r>
-                  <a:rPr lang="en-US" dirty="0"/>
-                  <a:t>Okafor et al.’s reduced mechanism (2019) accurately models NH3/air, NH3/CH4/air and H2/air flames.</a:t>
-                </a:r>
-              </a:p>
-              <a:p>
-                <a:r>
-                  <a:rPr lang="en-US" dirty="0"/>
-                  <a:t>Okafor et al.’s reduced mechanism (2019) fails to model NH3/H2/air flame when H2 concentration becomes significant (</a:t>
-                </a:r>
-                <a14:m>
-                  <m:oMath xmlns:m="http://schemas.openxmlformats.org/officeDocument/2006/math">
-                    <m:sSub>
-                      <m:sSubPr>
-                        <m:ctrlPr>
-                          <a:rPr lang="en-US" b="0" i="1" smtClean="0">
-                            <a:latin typeface="Cambria Math" panose="02040503050406030204" pitchFamily="18" charset="0"/>
-                          </a:rPr>
-                        </m:ctrlPr>
-                      </m:sSubPr>
-                      <m:e>
-                        <m:r>
-                          <a:rPr lang="en-US" b="0" i="1" smtClean="0">
-                            <a:latin typeface="Cambria Math" panose="02040503050406030204" pitchFamily="18" charset="0"/>
-                          </a:rPr>
-                          <m:t>𝑋</m:t>
-                        </m:r>
-                      </m:e>
-                      <m:sub>
-                        <m:r>
-                          <m:rPr>
-                            <m:sty m:val="p"/>
-                          </m:rPr>
-                          <a:rPr lang="en-US" b="0" i="0" smtClean="0">
-                            <a:latin typeface="Cambria Math" panose="02040503050406030204" pitchFamily="18" charset="0"/>
-                          </a:rPr>
-                          <m:t>H</m:t>
-                        </m:r>
-                        <m:r>
-                          <a:rPr lang="en-US" b="0" i="0" smtClean="0">
-                            <a:latin typeface="Cambria Math" panose="02040503050406030204" pitchFamily="18" charset="0"/>
-                          </a:rPr>
-                          <m:t>2</m:t>
-                        </m:r>
-                      </m:sub>
-                    </m:sSub>
-                    <m:r>
-                      <a:rPr lang="en-US" b="0" i="0" smtClean="0">
-                        <a:latin typeface="Cambria Math" panose="02040503050406030204" pitchFamily="18" charset="0"/>
-                      </a:rPr>
-                      <m:t>&gt;0.3</m:t>
-                    </m:r>
-                  </m:oMath>
-                </a14:m>
-                <a:r>
-                  <a:rPr lang="en-US" dirty="0"/>
-                  <a:t>).</a:t>
-                </a:r>
-              </a:p>
-              <a:p>
-                <a:r>
-                  <a:rPr lang="en-US" dirty="0"/>
-                  <a:t>Studying ammonia and hydrogen kinetics in NH3/H2/air reaction pathways to rectify this discrepancy.</a:t>
-                </a:r>
-              </a:p>
-              <a:p>
-                <a:endParaRPr lang="en-US" dirty="0"/>
-              </a:p>
-            </p:txBody>
-          </p:sp>
-        </mc:Choice>
-        <mc:Fallback xmlns="">
-          <p:sp>
-            <p:nvSpPr>
-              <p:cNvPr id="2" name="Content Placeholder 1">
-                <a:extLst>
-                  <a:ext uri="{FF2B5EF4-FFF2-40B4-BE49-F238E27FC236}">
-                    <a16:creationId xmlns:a16="http://schemas.microsoft.com/office/drawing/2014/main" id="{CBBCF3C5-C505-2F53-DE0B-D375D6591BD1}"/>
-                  </a:ext>
-                </a:extLst>
-              </p:cNvPr>
-              <p:cNvSpPr>
-                <a:spLocks noGrp="1" noRot="1" noChangeAspect="1" noMove="1" noResize="1" noEditPoints="1" noAdjustHandles="1" noChangeArrowheads="1" noChangeShapeType="1" noTextEdit="1"/>
-              </p:cNvSpPr>
-              <p:nvPr>
-                <p:ph idx="1"/>
-              </p:nvPr>
-            </p:nvSpPr>
-            <p:spPr>
-              <a:blipFill>
-                <a:blip r:embed="rId2"/>
-                <a:stretch>
-                  <a:fillRect l="-1683" t="-2168" r="-2552"/>
-                </a:stretch>
-              </a:blipFill>
-            </p:spPr>
-            <p:txBody>
-              <a:bodyPr/>
-              <a:lstStyle/>
-              <a:p>
-                <a:r>
-                  <a:rPr lang="en-US">
-                    <a:noFill/>
-                  </a:rPr>
-                  <a:t> </a:t>
-                </a:r>
-              </a:p>
-            </p:txBody>
-          </p:sp>
-        </mc:Fallback>
-      </mc:AlternateContent>
+      <p:sp>
+        <p:nvSpPr>
+          <p:cNvPr id="2" name="Content Placeholder 1">
+            <a:extLst>
+              <a:ext uri="{FF2B5EF4-FFF2-40B4-BE49-F238E27FC236}">
+                <a16:creationId xmlns:a16="http://schemas.microsoft.com/office/drawing/2014/main" id="{CBBCF3C5-C505-2F53-DE0B-D375D6591BD1}"/>
+              </a:ext>
+            </a:extLst>
+          </p:cNvPr>
+          <p:cNvSpPr>
+            <a:spLocks noGrp="1"/>
+          </p:cNvSpPr>
+          <p:nvPr>
+            <p:ph idx="1"/>
+          </p:nvPr>
+        </p:nvSpPr>
+        <p:spPr/>
+        <p:txBody>
+          <a:bodyPr/>
+          <a:lstStyle/>
+          <a:p>
+            <a:r>
+              <a:rPr lang="en-US" dirty="0"/>
+              <a:t>Existing reduced chemical kinetics mechanisms target specific fuel blends for select operating conditions.</a:t>
+            </a:r>
+          </a:p>
+          <a:p>
+            <a:r>
+              <a:rPr lang="en-US" dirty="0"/>
+              <a:t>Elucidating reaction pathways particular to specific fuel blends helped develop a kinetics mechanism viable for a wider range of fuels.</a:t>
+            </a:r>
+          </a:p>
+        </p:txBody>
+      </p:sp>
       <p:sp>
         <p:nvSpPr>
           <p:cNvPr id="3" name="Footer Placeholder 2">
@@ -6015,133 +5511,6 @@
 </file>
 
 <file path=ppt/slides/slide5.xml><?xml version="1.0" encoding="utf-8"?>
-<p:sld xmlns:a="http://schemas.openxmlformats.org/drawingml/2006/main" xmlns:r="http://schemas.openxmlformats.org/officeDocument/2006/relationships" xmlns:p="http://schemas.openxmlformats.org/presentationml/2006/main">
-  <p:cSld>
-    <p:spTree>
-      <p:nvGrpSpPr>
-        <p:cNvPr id="1" name=""/>
-        <p:cNvGrpSpPr/>
-        <p:nvPr/>
-      </p:nvGrpSpPr>
-      <p:grpSpPr>
-        <a:xfrm>
-          <a:off x="0" y="0"/>
-          <a:ext cx="0" cy="0"/>
-          <a:chOff x="0" y="0"/>
-          <a:chExt cx="0" cy="0"/>
-        </a:xfrm>
-      </p:grpSpPr>
-      <p:sp>
-        <p:nvSpPr>
-          <p:cNvPr id="2" name="Content Placeholder 1">
-            <a:extLst>
-              <a:ext uri="{FF2B5EF4-FFF2-40B4-BE49-F238E27FC236}">
-                <a16:creationId xmlns:a16="http://schemas.microsoft.com/office/drawing/2014/main" id="{37241CBB-F3AF-A104-7A22-52307796873D}"/>
-              </a:ext>
-            </a:extLst>
-          </p:cNvPr>
-          <p:cNvSpPr>
-            <a:spLocks noGrp="1"/>
-          </p:cNvSpPr>
-          <p:nvPr>
-            <p:ph idx="1"/>
-          </p:nvPr>
-        </p:nvSpPr>
-        <p:spPr/>
-        <p:txBody>
-          <a:bodyPr/>
-          <a:lstStyle/>
-          <a:p>
-            <a:endParaRPr lang="en-GB"/>
-          </a:p>
-        </p:txBody>
-      </p:sp>
-      <p:sp>
-        <p:nvSpPr>
-          <p:cNvPr id="3" name="Footer Placeholder 2">
-            <a:extLst>
-              <a:ext uri="{FF2B5EF4-FFF2-40B4-BE49-F238E27FC236}">
-                <a16:creationId xmlns:a16="http://schemas.microsoft.com/office/drawing/2014/main" id="{5F521A1D-93D2-0533-B590-CCD9CB8E7273}"/>
-              </a:ext>
-            </a:extLst>
-          </p:cNvPr>
-          <p:cNvSpPr>
-            <a:spLocks noGrp="1"/>
-          </p:cNvSpPr>
-          <p:nvPr>
-            <p:ph type="ftr" sz="quarter" idx="4294967295"/>
-          </p:nvPr>
-        </p:nvSpPr>
-        <p:spPr>
-          <a:xfrm>
-            <a:off x="762000" y="260648"/>
-            <a:ext cx="10014520" cy="381000"/>
-          </a:xfrm>
-        </p:spPr>
-        <p:txBody>
-          <a:bodyPr/>
-          <a:lstStyle/>
-          <a:p>
-            <a:pPr algn="l">
-              <a:defRPr/>
-            </a:pPr>
-            <a:r>
-              <a:rPr lang="en-US" altLang="ja-JP"/>
-              <a:t>Enter heading</a:t>
-            </a:r>
-            <a:endParaRPr lang="en-US" altLang="ja-JP" dirty="0"/>
-          </a:p>
-        </p:txBody>
-      </p:sp>
-      <p:sp>
-        <p:nvSpPr>
-          <p:cNvPr id="4" name="Slide Number Placeholder 3">
-            <a:extLst>
-              <a:ext uri="{FF2B5EF4-FFF2-40B4-BE49-F238E27FC236}">
-                <a16:creationId xmlns:a16="http://schemas.microsoft.com/office/drawing/2014/main" id="{5769097A-0E5D-C789-F187-35B5EA5C19AA}"/>
-              </a:ext>
-            </a:extLst>
-          </p:cNvPr>
-          <p:cNvSpPr>
-            <a:spLocks noGrp="1"/>
-          </p:cNvSpPr>
-          <p:nvPr>
-            <p:ph type="sldNum" sz="quarter" idx="11"/>
-          </p:nvPr>
-        </p:nvSpPr>
-        <p:spPr/>
-        <p:txBody>
-          <a:bodyPr/>
-          <a:lstStyle/>
-          <a:p>
-            <a:pPr>
-              <a:defRPr/>
-            </a:pPr>
-            <a:fld id="{F0030BFF-6758-4814-A89A-12C821A76488}" type="slidenum">
-              <a:rPr lang="en-US" altLang="ja-JP" smtClean="0"/>
-              <a:pPr>
-                <a:defRPr/>
-              </a:pPr>
-              <a:t>4</a:t>
-            </a:fld>
-            <a:endParaRPr lang="en-US" altLang="ja-JP"/>
-          </a:p>
-        </p:txBody>
-      </p:sp>
-    </p:spTree>
-    <p:extLst>
-      <p:ext uri="{BB962C8B-B14F-4D97-AF65-F5344CB8AC3E}">
-        <p14:creationId xmlns:p14="http://schemas.microsoft.com/office/powerpoint/2010/main" val="3884861768"/>
-      </p:ext>
-    </p:extLst>
-  </p:cSld>
-  <p:clrMapOvr>
-    <a:masterClrMapping/>
-  </p:clrMapOvr>
-</p:sld>
-</file>
-
-<file path=ppt/slides/slide6.xml><?xml version="1.0" encoding="utf-8"?>
 <p:sld xmlns:a="http://schemas.openxmlformats.org/drawingml/2006/main" xmlns:r="http://schemas.openxmlformats.org/officeDocument/2006/relationships" xmlns:p="http://schemas.openxmlformats.org/presentationml/2006/main">
   <p:cSld>
     <p:spTree>
@@ -6431,7 +5800,7 @@
               <a:pPr>
                 <a:defRPr/>
               </a:pPr>
-              <a:t>5</a:t>
+              <a:t>4</a:t>
             </a:fld>
             <a:endParaRPr lang="en-US" altLang="ja-JP"/>
           </a:p>
@@ -6450,7 +5819,7 @@
 </p:sld>
 </file>
 
-<file path=ppt/slides/slide7.xml><?xml version="1.0" encoding="utf-8"?>
+<file path=ppt/slides/slide6.xml><?xml version="1.0" encoding="utf-8"?>
 <p:sld xmlns:a="http://schemas.openxmlformats.org/drawingml/2006/main" xmlns:r="http://schemas.openxmlformats.org/officeDocument/2006/relationships" xmlns:p="http://schemas.openxmlformats.org/presentationml/2006/main">
   <p:cSld>
     <p:spTree>
@@ -6691,7 +6060,7 @@
               <a:pPr>
                 <a:defRPr/>
               </a:pPr>
-              <a:t>6</a:t>
+              <a:t>5</a:t>
             </a:fld>
             <a:endParaRPr lang="en-US" altLang="ja-JP"/>
           </a:p>
@@ -6710,7 +6079,7 @@
 </p:sld>
 </file>
 
-<file path=ppt/slides/slide8.xml><?xml version="1.0" encoding="utf-8"?>
+<file path=ppt/slides/slide7.xml><?xml version="1.0" encoding="utf-8"?>
 <p:sld xmlns:a="http://schemas.openxmlformats.org/drawingml/2006/main" xmlns:r="http://schemas.openxmlformats.org/officeDocument/2006/relationships" xmlns:p="http://schemas.openxmlformats.org/presentationml/2006/main">
   <p:cSld>
     <p:spTree>
@@ -6826,7 +6195,7 @@
               <a:pPr>
                 <a:defRPr/>
               </a:pPr>
-              <a:t>7</a:t>
+              <a:t>6</a:t>
             </a:fld>
             <a:endParaRPr lang="en-US" altLang="ja-JP"/>
           </a:p>
@@ -6880,7 +6249,7 @@
 </p:sld>
 </file>
 
-<file path=ppt/slides/slide9.xml><?xml version="1.0" encoding="utf-8"?>
+<file path=ppt/slides/slide8.xml><?xml version="1.0" encoding="utf-8"?>
 <p:sld xmlns:a="http://schemas.openxmlformats.org/drawingml/2006/main" xmlns:r="http://schemas.openxmlformats.org/officeDocument/2006/relationships" xmlns:p="http://schemas.openxmlformats.org/presentationml/2006/main">
   <p:cSld>
     <p:spTree>
@@ -7204,7 +6573,7 @@
               <a:pPr>
                 <a:defRPr/>
               </a:pPr>
-              <a:t>8</a:t>
+              <a:t>7</a:t>
             </a:fld>
             <a:endParaRPr lang="en-US" altLang="ja-JP"/>
           </a:p>
@@ -7214,6 +6583,356 @@
     <p:extLst>
       <p:ext uri="{BB962C8B-B14F-4D97-AF65-F5344CB8AC3E}">
         <p14:creationId xmlns:p14="http://schemas.microsoft.com/office/powerpoint/2010/main" val="3075110359"/>
+      </p:ext>
+    </p:extLst>
+  </p:cSld>
+  <p:clrMapOvr>
+    <a:masterClrMapping/>
+  </p:clrMapOvr>
+</p:sld>
+</file>
+
+<file path=ppt/slides/slide9.xml><?xml version="1.0" encoding="utf-8"?>
+<p:sld xmlns:a="http://schemas.openxmlformats.org/drawingml/2006/main" xmlns:r="http://schemas.openxmlformats.org/officeDocument/2006/relationships" xmlns:p="http://schemas.openxmlformats.org/presentationml/2006/main">
+  <p:cSld>
+    <p:spTree>
+      <p:nvGrpSpPr>
+        <p:cNvPr id="1" name=""/>
+        <p:cNvGrpSpPr/>
+        <p:nvPr/>
+      </p:nvGrpSpPr>
+      <p:grpSpPr>
+        <a:xfrm>
+          <a:off x="0" y="0"/>
+          <a:ext cx="0" cy="0"/>
+          <a:chOff x="0" y="0"/>
+          <a:chExt cx="0" cy="0"/>
+        </a:xfrm>
+      </p:grpSpPr>
+      <p:pic>
+        <p:nvPicPr>
+          <p:cNvPr id="9" name="Content Placeholder 8">
+            <a:extLst>
+              <a:ext uri="{FF2B5EF4-FFF2-40B4-BE49-F238E27FC236}">
+                <a16:creationId xmlns:a16="http://schemas.microsoft.com/office/drawing/2014/main" id="{90D67F15-3E02-AC3D-E2FC-D73F68793F8C}"/>
+              </a:ext>
+            </a:extLst>
+          </p:cNvPr>
+          <p:cNvPicPr>
+            <a:picLocks noGrp="1" noChangeAspect="1"/>
+          </p:cNvPicPr>
+          <p:nvPr>
+            <p:ph idx="1"/>
+          </p:nvPr>
+        </p:nvPicPr>
+        <p:blipFill>
+          <a:blip r:embed="rId3" cstate="print">
+            <a:extLst>
+              <a:ext uri="{28A0092B-C50C-407E-A947-70E740481C1C}">
+                <a14:useLocalDpi xmlns:a14="http://schemas.microsoft.com/office/drawing/2010/main" val="0"/>
+              </a:ext>
+            </a:extLst>
+          </a:blip>
+          <a:stretch>
+            <a:fillRect/>
+          </a:stretch>
+        </p:blipFill>
+        <p:spPr>
+          <a:xfrm>
+            <a:off x="750407" y="1152907"/>
+            <a:ext cx="10691186" cy="4043485"/>
+          </a:xfrm>
+        </p:spPr>
+      </p:pic>
+      <p:sp>
+        <p:nvSpPr>
+          <p:cNvPr id="6" name="Footer Placeholder 5">
+            <a:extLst>
+              <a:ext uri="{FF2B5EF4-FFF2-40B4-BE49-F238E27FC236}">
+                <a16:creationId xmlns:a16="http://schemas.microsoft.com/office/drawing/2014/main" id="{DEB392FD-A7DC-53D3-86AA-59DB820A8B3D}"/>
+              </a:ext>
+            </a:extLst>
+          </p:cNvPr>
+          <p:cNvSpPr>
+            <a:spLocks noGrp="1"/>
+          </p:cNvSpPr>
+          <p:nvPr>
+            <p:ph type="ftr" sz="quarter" idx="4294967295"/>
+          </p:nvPr>
+        </p:nvSpPr>
+        <p:spPr>
+          <a:xfrm>
+            <a:off x="762000" y="260648"/>
+            <a:ext cx="10014520" cy="381000"/>
+          </a:xfrm>
+        </p:spPr>
+        <p:txBody>
+          <a:bodyPr/>
+          <a:lstStyle/>
+          <a:p>
+            <a:pPr algn="l">
+              <a:defRPr/>
+            </a:pPr>
+            <a:r>
+              <a:rPr lang="en-US" altLang="ja-JP" dirty="0"/>
+              <a:t>Development of the Present Mech</a:t>
+            </a:r>
+          </a:p>
+        </p:txBody>
+      </p:sp>
+      <p:sp>
+        <p:nvSpPr>
+          <p:cNvPr id="5" name="Slide Number Placeholder 4">
+            <a:extLst>
+              <a:ext uri="{FF2B5EF4-FFF2-40B4-BE49-F238E27FC236}">
+                <a16:creationId xmlns:a16="http://schemas.microsoft.com/office/drawing/2014/main" id="{1E9C4219-3EB0-B365-10B3-08342118FE65}"/>
+              </a:ext>
+            </a:extLst>
+          </p:cNvPr>
+          <p:cNvSpPr>
+            <a:spLocks noGrp="1"/>
+          </p:cNvSpPr>
+          <p:nvPr>
+            <p:ph type="sldNum" sz="quarter" idx="11"/>
+          </p:nvPr>
+        </p:nvSpPr>
+        <p:spPr/>
+        <p:txBody>
+          <a:bodyPr/>
+          <a:lstStyle/>
+          <a:p>
+            <a:pPr>
+              <a:defRPr/>
+            </a:pPr>
+            <a:fld id="{5E160AE0-185D-4321-8E65-BC536618BE04}" type="slidenum">
+              <a:rPr lang="en-US" altLang="ja-JP" smtClean="0"/>
+              <a:pPr>
+                <a:defRPr/>
+              </a:pPr>
+              <a:t>8</a:t>
+            </a:fld>
+            <a:endParaRPr lang="en-US" altLang="ja-JP"/>
+          </a:p>
+        </p:txBody>
+      </p:sp>
+      <mc:AlternateContent xmlns:mc="http://schemas.openxmlformats.org/markup-compatibility/2006" xmlns:a14="http://schemas.microsoft.com/office/drawing/2010/main">
+        <mc:Choice Requires="a14">
+          <p:sp>
+            <p:nvSpPr>
+              <p:cNvPr id="10" name="TextBox 9">
+                <a:extLst>
+                  <a:ext uri="{FF2B5EF4-FFF2-40B4-BE49-F238E27FC236}">
+                    <a16:creationId xmlns:a16="http://schemas.microsoft.com/office/drawing/2014/main" id="{1E12F815-FBBD-6F5C-6657-204ABE3DAB9A}"/>
+                  </a:ext>
+                </a:extLst>
+              </p:cNvPr>
+              <p:cNvSpPr txBox="1"/>
+              <p:nvPr/>
+            </p:nvSpPr>
+            <p:spPr>
+              <a:xfrm>
+                <a:off x="762000" y="5473387"/>
+                <a:ext cx="10662592" cy="907941"/>
+              </a:xfrm>
+              <a:prstGeom prst="rect">
+                <a:avLst/>
+              </a:prstGeom>
+              <a:noFill/>
+            </p:spPr>
+            <p:txBody>
+              <a:bodyPr wrap="square" rtlCol="0">
+                <a:spAutoFit/>
+              </a:bodyPr>
+              <a:lstStyle/>
+              <a:p>
+                <a:r>
+                  <a:rPr lang="en-US" sz="1600" dirty="0"/>
+                  <a:t>			(a)						(b)</a:t>
+                </a:r>
+              </a:p>
+              <a:p>
+                <a:endParaRPr lang="en-US" sz="900" dirty="0"/>
+              </a:p>
+              <a:p>
+                <a:r>
+                  <a:rPr lang="en-US" sz="1400" dirty="0"/>
+                  <a:t>Figure: Reaction pathway of NH3/H2/air flame at </a:t>
+                </a:r>
+                <a14:m>
+                  <m:oMath xmlns:m="http://schemas.openxmlformats.org/officeDocument/2006/math">
+                    <m:sSub>
+                      <m:sSubPr>
+                        <m:ctrlPr>
+                          <a:rPr lang="en-US" sz="1400" b="0" i="1" smtClean="0">
+                            <a:latin typeface="Cambria Math" panose="02040503050406030204" pitchFamily="18" charset="0"/>
+                          </a:rPr>
+                        </m:ctrlPr>
+                      </m:sSubPr>
+                      <m:e>
+                        <m:r>
+                          <a:rPr lang="en-US" sz="1400" b="0" i="1" smtClean="0">
+                            <a:latin typeface="Cambria Math" panose="02040503050406030204" pitchFamily="18" charset="0"/>
+                          </a:rPr>
+                          <m:t>𝑋</m:t>
+                        </m:r>
+                      </m:e>
+                      <m:sub>
+                        <m:r>
+                          <m:rPr>
+                            <m:sty m:val="p"/>
+                          </m:rPr>
+                          <a:rPr lang="en-US" sz="1400" b="0" i="0" smtClean="0">
+                            <a:latin typeface="Cambria Math" panose="02040503050406030204" pitchFamily="18" charset="0"/>
+                          </a:rPr>
+                          <m:t>H</m:t>
+                        </m:r>
+                        <m:r>
+                          <a:rPr lang="en-US" sz="1400" b="0" i="0" smtClean="0">
+                            <a:latin typeface="Cambria Math" panose="02040503050406030204" pitchFamily="18" charset="0"/>
+                          </a:rPr>
+                          <m:t>2</m:t>
+                        </m:r>
+                      </m:sub>
+                    </m:sSub>
+                    <m:r>
+                      <a:rPr lang="en-US" sz="1400" b="0" i="1" smtClean="0">
+                        <a:latin typeface="Cambria Math" panose="02040503050406030204" pitchFamily="18" charset="0"/>
+                      </a:rPr>
+                      <m:t>=0.5</m:t>
+                    </m:r>
+                  </m:oMath>
+                </a14:m>
+                <a:r>
+                  <a:rPr lang="en-US" sz="1400" dirty="0"/>
+                  <a:t> and equivalence ratio of 1.0 using (a) Okafor Reduced Mech and (b) Gotama Mech.</a:t>
+                </a:r>
+              </a:p>
+            </p:txBody>
+          </p:sp>
+        </mc:Choice>
+        <mc:Fallback xmlns="">
+          <p:sp>
+            <p:nvSpPr>
+              <p:cNvPr id="10" name="TextBox 9">
+                <a:extLst>
+                  <a:ext uri="{FF2B5EF4-FFF2-40B4-BE49-F238E27FC236}">
+                    <a16:creationId xmlns:a16="http://schemas.microsoft.com/office/drawing/2014/main" id="{1E12F815-FBBD-6F5C-6657-204ABE3DAB9A}"/>
+                  </a:ext>
+                </a:extLst>
+              </p:cNvPr>
+              <p:cNvSpPr txBox="1">
+                <a:spLocks noRot="1" noChangeAspect="1" noMove="1" noResize="1" noEditPoints="1" noAdjustHandles="1" noChangeArrowheads="1" noChangeShapeType="1" noTextEdit="1"/>
+              </p:cNvSpPr>
+              <p:nvPr/>
+            </p:nvSpPr>
+            <p:spPr>
+              <a:xfrm>
+                <a:off x="762000" y="5473387"/>
+                <a:ext cx="10662592" cy="907941"/>
+              </a:xfrm>
+              <a:prstGeom prst="rect">
+                <a:avLst/>
+              </a:prstGeom>
+              <a:blipFill>
+                <a:blip r:embed="rId4"/>
+                <a:stretch>
+                  <a:fillRect l="-172" t="-2013" b="-6040"/>
+                </a:stretch>
+              </a:blipFill>
+            </p:spPr>
+            <p:txBody>
+              <a:bodyPr/>
+              <a:lstStyle/>
+              <a:p>
+                <a:r>
+                  <a:rPr lang="en-US">
+                    <a:noFill/>
+                  </a:rPr>
+                  <a:t> </a:t>
+                </a:r>
+              </a:p>
+            </p:txBody>
+          </p:sp>
+        </mc:Fallback>
+      </mc:AlternateContent>
+      <p:sp>
+        <p:nvSpPr>
+          <p:cNvPr id="11" name="TextBox 10">
+            <a:extLst>
+              <a:ext uri="{FF2B5EF4-FFF2-40B4-BE49-F238E27FC236}">
+                <a16:creationId xmlns:a16="http://schemas.microsoft.com/office/drawing/2014/main" id="{FC4FD694-35C0-7260-D6C0-0D6F732C40DC}"/>
+              </a:ext>
+            </a:extLst>
+          </p:cNvPr>
+          <p:cNvSpPr txBox="1"/>
+          <p:nvPr/>
+        </p:nvSpPr>
+        <p:spPr>
+          <a:xfrm>
+            <a:off x="2927648" y="4579992"/>
+            <a:ext cx="576064" cy="107722"/>
+          </a:xfrm>
+          <a:prstGeom prst="rect">
+            <a:avLst/>
+          </a:prstGeom>
+          <a:solidFill>
+            <a:schemeClr val="bg1"/>
+          </a:solidFill>
+        </p:spPr>
+        <p:txBody>
+          <a:bodyPr wrap="square" lIns="0" tIns="0" rIns="0" bIns="0" rtlCol="0">
+            <a:spAutoFit/>
+          </a:bodyPr>
+          <a:lstStyle/>
+          <a:p>
+            <a:r>
+              <a:rPr lang="en-US" sz="700" dirty="0"/>
+              <a:t>Unimolecular</a:t>
+            </a:r>
+          </a:p>
+        </p:txBody>
+      </p:sp>
+      <p:sp>
+        <p:nvSpPr>
+          <p:cNvPr id="13" name="TextBox 12">
+            <a:extLst>
+              <a:ext uri="{FF2B5EF4-FFF2-40B4-BE49-F238E27FC236}">
+                <a16:creationId xmlns:a16="http://schemas.microsoft.com/office/drawing/2014/main" id="{BD85B8B6-BF69-9E8C-1E1C-1C7179046A5E}"/>
+              </a:ext>
+            </a:extLst>
+          </p:cNvPr>
+          <p:cNvSpPr txBox="1"/>
+          <p:nvPr/>
+        </p:nvSpPr>
+        <p:spPr>
+          <a:xfrm>
+            <a:off x="8293608" y="4096512"/>
+            <a:ext cx="576064" cy="107722"/>
+          </a:xfrm>
+          <a:prstGeom prst="rect">
+            <a:avLst/>
+          </a:prstGeom>
+          <a:solidFill>
+            <a:schemeClr val="bg1"/>
+          </a:solidFill>
+        </p:spPr>
+        <p:txBody>
+          <a:bodyPr wrap="square" lIns="0" tIns="0" rIns="0" bIns="0" rtlCol="0">
+            <a:spAutoFit/>
+          </a:bodyPr>
+          <a:lstStyle/>
+          <a:p>
+            <a:r>
+              <a:rPr lang="en-US" sz="700" dirty="0"/>
+              <a:t>Unimolecular</a:t>
+            </a:r>
+          </a:p>
+        </p:txBody>
+      </p:sp>
+    </p:spTree>
+    <p:extLst>
+      <p:ext uri="{BB962C8B-B14F-4D97-AF65-F5344CB8AC3E}">
+        <p14:creationId xmlns:p14="http://schemas.microsoft.com/office/powerpoint/2010/main" val="1550952523"/>
       </p:ext>
     </p:extLst>
   </p:cSld>
@@ -8543,15 +8262,6 @@
 </file>
 
 <file path=customXml/item1.xml><?xml version="1.0" encoding="utf-8"?>
-<?mso-contentType ?>
-<FormTemplates xmlns="http://schemas.microsoft.com/sharepoint/v3/contenttype/forms">
-  <Display>DocumentLibraryForm</Display>
-  <Edit>DocumentLibraryForm</Edit>
-  <New>DocumentLibraryForm</New>
-</FormTemplates>
-</file>
-
-<file path=customXml/item2.xml><?xml version="1.0" encoding="utf-8"?>
 <ct:contentTypeSchema xmlns:ct="http://schemas.microsoft.com/office/2006/metadata/contentType" xmlns:ma="http://schemas.microsoft.com/office/2006/metadata/properties/metaAttributes" ct:_="" ma:_="" ma:contentTypeName="ドキュメント" ma:contentTypeID="0x010100AC715DFC87AEC746B6E619DC903AC002" ma:contentTypeVersion="13" ma:contentTypeDescription="新しいドキュメントを作成します。" ma:contentTypeScope="" ma:versionID="aa17f1492cbf83ee66dd3c5755e3c0c8">
   <xsd:schema xmlns:xsd="http://www.w3.org/2001/XMLSchema" xmlns:xs="http://www.w3.org/2001/XMLSchema" xmlns:p="http://schemas.microsoft.com/office/2006/metadata/properties" xmlns:ns3="4c4639b9-ffc3-40db-9ad9-f2d2fa56049e" xmlns:ns4="5300894c-015e-4e73-9e9a-c62eb38f0dbe" targetNamespace="http://schemas.microsoft.com/office/2006/metadata/properties" ma:root="true" ma:fieldsID="972fc8aede851579bc776d06a2daffa5" ns3:_="" ns4:_="">
     <xsd:import namespace="4c4639b9-ffc3-40db-9ad9-f2d2fa56049e"/>
@@ -8774,6 +8484,15 @@
 </ct:contentTypeSchema>
 </file>
 
+<file path=customXml/item2.xml><?xml version="1.0" encoding="utf-8"?>
+<?mso-contentType ?>
+<FormTemplates xmlns="http://schemas.microsoft.com/sharepoint/v3/contenttype/forms">
+  <Display>DocumentLibraryForm</Display>
+  <Edit>DocumentLibraryForm</Edit>
+  <New>DocumentLibraryForm</New>
+</FormTemplates>
+</file>
+
 <file path=customXml/item3.xml><?xml version="1.0" encoding="utf-8"?>
 <p:properties xmlns:p="http://schemas.microsoft.com/office/2006/metadata/properties" xmlns:xsi="http://www.w3.org/2001/XMLSchema-instance" xmlns:pc="http://schemas.microsoft.com/office/infopath/2007/PartnerControls">
   <documentManagement/>
@@ -8781,14 +8500,6 @@
 </file>
 
 <file path=customXml/itemProps1.xml><?xml version="1.0" encoding="utf-8"?>
-<ds:datastoreItem xmlns:ds="http://schemas.openxmlformats.org/officeDocument/2006/customXml" ds:itemID="{9C6B76C4-5C7C-488F-A583-DEEA7B62FA01}">
-  <ds:schemaRefs>
-    <ds:schemaRef ds:uri="http://schemas.microsoft.com/sharepoint/v3/contenttype/forms"/>
-  </ds:schemaRefs>
-</ds:datastoreItem>
-</file>
-
-<file path=customXml/itemProps2.xml><?xml version="1.0" encoding="utf-8"?>
 <ds:datastoreItem xmlns:ds="http://schemas.openxmlformats.org/officeDocument/2006/customXml" ds:itemID="{7ABEC41F-200F-4D36-8A42-5C9C15374455}">
   <ds:schemaRefs>
     <ds:schemaRef ds:uri="http://schemas.microsoft.com/office/2006/metadata/contentType"/>
@@ -8803,6 +8514,14 @@
     <ds:schemaRef ds:uri="http://purl.org/dc/elements/1.1/"/>
     <ds:schemaRef ds:uri="http://purl.org/dc/terms/"/>
     <ds:schemaRef ds:uri="http://schemas.microsoft.com/internal/obd"/>
+  </ds:schemaRefs>
+</ds:datastoreItem>
+</file>
+
+<file path=customXml/itemProps2.xml><?xml version="1.0" encoding="utf-8"?>
+<ds:datastoreItem xmlns:ds="http://schemas.openxmlformats.org/officeDocument/2006/customXml" ds:itemID="{9C6B76C4-5C7C-488F-A583-DEEA7B62FA01}">
+  <ds:schemaRefs>
+    <ds:schemaRef ds:uri="http://schemas.microsoft.com/sharepoint/v3/contenttype/forms"/>
   </ds:schemaRefs>
 </ds:datastoreItem>
 </file>

</xml_diff>

<commit_message>
changes to draft 1
</commit_message>
<xml_diff>
--- a/icfd2026/pres/kyushu_ppt_16-9.pptx
+++ b/icfd2026/pres/kyushu_ppt_16-9.pptx
@@ -265,7 +265,7 @@
               <a:pPr>
                 <a:defRPr/>
               </a:pPr>
-              <a:t>2026/10/15</a:t>
+              <a:t>2026/10/20</a:t>
             </a:fld>
             <a:endParaRPr lang="ja-JP" altLang="en-US"/>
           </a:p>
@@ -1046,7 +1046,7 @@
               </a:pPr>
               <a:t>0</a:t>
             </a:fld>
-            <a:endParaRPr lang="en-US" altLang="ja-JP"/>
+            <a:endParaRPr lang="en-US" altLang="ja-JP" dirty="0"/>
           </a:p>
         </p:txBody>
       </p:sp>
@@ -1100,6 +1100,198 @@
         </p:txBody>
       </p:sp>
     </p:spTree>
+  </p:cSld>
+  <p:clrMapOvr>
+    <a:masterClrMapping/>
+  </p:clrMapOvr>
+</p:notes>
+</file>
+
+<file path=ppt/notesSlides/notesSlide10.xml><?xml version="1.0" encoding="utf-8"?>
+<p:notes xmlns:a="http://schemas.openxmlformats.org/drawingml/2006/main" xmlns:r="http://schemas.openxmlformats.org/officeDocument/2006/relationships" xmlns:p="http://schemas.openxmlformats.org/presentationml/2006/main">
+  <p:cSld>
+    <p:spTree>
+      <p:nvGrpSpPr>
+        <p:cNvPr id="1" name=""/>
+        <p:cNvGrpSpPr/>
+        <p:nvPr/>
+      </p:nvGrpSpPr>
+      <p:grpSpPr>
+        <a:xfrm>
+          <a:off x="0" y="0"/>
+          <a:ext cx="0" cy="0"/>
+          <a:chOff x="0" y="0"/>
+          <a:chExt cx="0" cy="0"/>
+        </a:xfrm>
+      </p:grpSpPr>
+      <p:sp>
+        <p:nvSpPr>
+          <p:cNvPr id="2" name="Slide Image Placeholder 1"/>
+          <p:cNvSpPr>
+            <a:spLocks noGrp="1" noRot="1" noChangeAspect="1"/>
+          </p:cNvSpPr>
+          <p:nvPr>
+            <p:ph type="sldImg"/>
+          </p:nvPr>
+        </p:nvSpPr>
+        <p:spPr/>
+      </p:sp>
+      <p:sp>
+        <p:nvSpPr>
+          <p:cNvPr id="3" name="Notes Placeholder 2"/>
+          <p:cNvSpPr>
+            <a:spLocks noGrp="1"/>
+          </p:cNvSpPr>
+          <p:nvPr>
+            <p:ph type="body" idx="1"/>
+          </p:nvPr>
+        </p:nvSpPr>
+        <p:spPr/>
+        <p:txBody>
+          <a:bodyPr/>
+          <a:lstStyle/>
+          <a:p>
+            <a:r>
+              <a:rPr lang="en-US" dirty="0"/>
+              <a:t>Unable to validate for elevated pressures due to a lack of experimental  data</a:t>
+            </a:r>
+          </a:p>
+        </p:txBody>
+      </p:sp>
+      <p:sp>
+        <p:nvSpPr>
+          <p:cNvPr id="4" name="Slide Number Placeholder 3"/>
+          <p:cNvSpPr>
+            <a:spLocks noGrp="1"/>
+          </p:cNvSpPr>
+          <p:nvPr>
+            <p:ph type="sldNum" sz="quarter" idx="5"/>
+          </p:nvPr>
+        </p:nvSpPr>
+        <p:spPr/>
+        <p:txBody>
+          <a:bodyPr/>
+          <a:lstStyle/>
+          <a:p>
+            <a:pPr>
+              <a:defRPr/>
+            </a:pPr>
+            <a:fld id="{ACB89EC6-F31B-4A18-90F4-42C2071FB0B9}" type="slidenum">
+              <a:rPr lang="en-US" altLang="ja-JP" smtClean="0"/>
+              <a:pPr>
+                <a:defRPr/>
+              </a:pPr>
+              <a:t>11</a:t>
+            </a:fld>
+            <a:endParaRPr lang="en-US" altLang="ja-JP"/>
+          </a:p>
+        </p:txBody>
+      </p:sp>
+    </p:spTree>
+    <p:extLst>
+      <p:ext uri="{BB962C8B-B14F-4D97-AF65-F5344CB8AC3E}">
+        <p14:creationId xmlns:p14="http://schemas.microsoft.com/office/powerpoint/2010/main" val="1885764697"/>
+      </p:ext>
+    </p:extLst>
+  </p:cSld>
+  <p:clrMapOvr>
+    <a:masterClrMapping/>
+  </p:clrMapOvr>
+</p:notes>
+</file>
+
+<file path=ppt/notesSlides/notesSlide11.xml><?xml version="1.0" encoding="utf-8"?>
+<p:notes xmlns:a="http://schemas.openxmlformats.org/drawingml/2006/main" xmlns:r="http://schemas.openxmlformats.org/officeDocument/2006/relationships" xmlns:p="http://schemas.openxmlformats.org/presentationml/2006/main">
+  <p:cSld>
+    <p:spTree>
+      <p:nvGrpSpPr>
+        <p:cNvPr id="1" name=""/>
+        <p:cNvGrpSpPr/>
+        <p:nvPr/>
+      </p:nvGrpSpPr>
+      <p:grpSpPr>
+        <a:xfrm>
+          <a:off x="0" y="0"/>
+          <a:ext cx="0" cy="0"/>
+          <a:chOff x="0" y="0"/>
+          <a:chExt cx="0" cy="0"/>
+        </a:xfrm>
+      </p:grpSpPr>
+      <p:sp>
+        <p:nvSpPr>
+          <p:cNvPr id="2" name="Slide Image Placeholder 1"/>
+          <p:cNvSpPr>
+            <a:spLocks noGrp="1" noRot="1" noChangeAspect="1"/>
+          </p:cNvSpPr>
+          <p:nvPr>
+            <p:ph type="sldImg"/>
+          </p:nvPr>
+        </p:nvSpPr>
+        <p:spPr/>
+      </p:sp>
+      <p:sp>
+        <p:nvSpPr>
+          <p:cNvPr id="3" name="Notes Placeholder 2"/>
+          <p:cNvSpPr>
+            <a:spLocks noGrp="1"/>
+          </p:cNvSpPr>
+          <p:nvPr>
+            <p:ph type="body" idx="1"/>
+          </p:nvPr>
+        </p:nvSpPr>
+        <p:spPr/>
+        <p:txBody>
+          <a:bodyPr/>
+          <a:lstStyle/>
+          <a:p>
+            <a:r>
+              <a:rPr lang="en-US" dirty="0"/>
+              <a:t>Make sure graph starts at 0,0</a:t>
+            </a:r>
+          </a:p>
+          <a:p>
+            <a:r>
+              <a:rPr lang="en-US" dirty="0"/>
+              <a:t>Explain why N2Hx pathways do not affect nh3/ch4 flames</a:t>
+            </a:r>
+          </a:p>
+        </p:txBody>
+      </p:sp>
+      <p:sp>
+        <p:nvSpPr>
+          <p:cNvPr id="4" name="Slide Number Placeholder 3"/>
+          <p:cNvSpPr>
+            <a:spLocks noGrp="1"/>
+          </p:cNvSpPr>
+          <p:nvPr>
+            <p:ph type="sldNum" sz="quarter" idx="5"/>
+          </p:nvPr>
+        </p:nvSpPr>
+        <p:spPr/>
+        <p:txBody>
+          <a:bodyPr/>
+          <a:lstStyle/>
+          <a:p>
+            <a:pPr>
+              <a:defRPr/>
+            </a:pPr>
+            <a:fld id="{ACB89EC6-F31B-4A18-90F4-42C2071FB0B9}" type="slidenum">
+              <a:rPr lang="en-US" altLang="ja-JP" smtClean="0"/>
+              <a:pPr>
+                <a:defRPr/>
+              </a:pPr>
+              <a:t>12</a:t>
+            </a:fld>
+            <a:endParaRPr lang="en-US" altLang="ja-JP"/>
+          </a:p>
+        </p:txBody>
+      </p:sp>
+    </p:spTree>
+    <p:extLst>
+      <p:ext uri="{BB962C8B-B14F-4D97-AF65-F5344CB8AC3E}">
+        <p14:creationId xmlns:p14="http://schemas.microsoft.com/office/powerpoint/2010/main" val="1977750115"/>
+      </p:ext>
+    </p:extLst>
   </p:cSld>
   <p:clrMapOvr>
     <a:masterClrMapping/>
@@ -1153,7 +1345,30 @@
           <a:p>
             <a:r>
               <a:rPr lang="en-US" dirty="0"/>
-              <a:t>Figure of combustor </a:t>
+              <a:t>Include importance of ammonia combustion simulation</a:t>
+            </a:r>
+          </a:p>
+          <a:p>
+            <a:r>
+              <a:rPr lang="en-US" dirty="0"/>
+              <a:t>	for emission control </a:t>
+            </a:r>
+            <a:r>
+              <a:rPr lang="en-US" dirty="0" err="1"/>
+              <a:t>etc</a:t>
+            </a:r>
+            <a:endParaRPr lang="en-US" dirty="0"/>
+          </a:p>
+          <a:p>
+            <a:r>
+              <a:rPr lang="en-US" dirty="0"/>
+              <a:t>Lesser whitespace</a:t>
+            </a:r>
+          </a:p>
+          <a:p>
+            <a:r>
+              <a:rPr lang="en-US" dirty="0"/>
+              <a:t>Figures relevant to talking points</a:t>
             </a:r>
           </a:p>
         </p:txBody>
@@ -1244,7 +1459,10 @@
           <a:bodyPr/>
           <a:lstStyle/>
           <a:p>
-            <a:endParaRPr lang="en-US" dirty="0"/>
+            <a:r>
+              <a:rPr lang="en-US" dirty="0"/>
+              <a:t>Change images; unclear as to what the image represents</a:t>
+            </a:r>
           </a:p>
         </p:txBody>
       </p:sp>
@@ -1271,7 +1489,7 @@
               <a:pPr>
                 <a:defRPr/>
               </a:pPr>
-              <a:t>8</a:t>
+              <a:t>2</a:t>
             </a:fld>
             <a:endParaRPr lang="en-US" altLang="ja-JP"/>
           </a:p>
@@ -1280,7 +1498,7 @@
     </p:spTree>
     <p:extLst>
       <p:ext uri="{BB962C8B-B14F-4D97-AF65-F5344CB8AC3E}">
-        <p14:creationId xmlns:p14="http://schemas.microsoft.com/office/powerpoint/2010/main" val="3534912427"/>
+        <p14:creationId xmlns:p14="http://schemas.microsoft.com/office/powerpoint/2010/main" val="3624717304"/>
       </p:ext>
     </p:extLst>
   </p:cSld>
@@ -1336,19 +1554,41 @@
           <a:p>
             <a:r>
               <a:rPr lang="en-US" dirty="0"/>
-              <a:t>1,2,3 control H radicals conc</a:t>
-            </a:r>
-          </a:p>
-          <a:p>
+              <a:t>Okafor mech fails nh3/h2 </a:t>
+            </a:r>
+            <a:r>
+              <a:rPr lang="en-US" dirty="0" err="1"/>
+              <a:t>lbv</a:t>
+            </a:r>
             <a:r>
               <a:rPr lang="en-US" dirty="0"/>
-              <a:t>1,2 control NH and NH2 conc</a:t>
+              <a:t> modeling because mech not developed for this blend</a:t>
             </a:r>
           </a:p>
           <a:p>
             <a:r>
               <a:rPr lang="en-US" dirty="0"/>
-              <a:t>	NHx interact with H and OH </a:t>
+              <a:t>Explain why </a:t>
+            </a:r>
+            <a:r>
+              <a:rPr lang="en-US" dirty="0" err="1"/>
+              <a:t>gotama</a:t>
+            </a:r>
+            <a:r>
+              <a:rPr lang="en-US" dirty="0"/>
+              <a:t> mech selected</a:t>
+            </a:r>
+          </a:p>
+          <a:p>
+            <a:r>
+              <a:rPr lang="en-US" dirty="0"/>
+              <a:t>	“a reaction mechanism developed for nh3/h2 flame selected to STUDY nh3/h2 flame chemistry”</a:t>
+            </a:r>
+          </a:p>
+          <a:p>
+            <a:r>
+              <a:rPr lang="en-US" dirty="0"/>
+              <a:t>Don’t say compare. Emphasis on how other mechanisms were used to study the chemistry.</a:t>
             </a:r>
           </a:p>
         </p:txBody>
@@ -1376,7 +1616,7 @@
               <a:pPr>
                 <a:defRPr/>
               </a:pPr>
-              <a:t>9</a:t>
+              <a:t>4</a:t>
             </a:fld>
             <a:endParaRPr lang="en-US" altLang="ja-JP"/>
           </a:p>
@@ -1385,7 +1625,7 @@
     </p:spTree>
     <p:extLst>
       <p:ext uri="{BB962C8B-B14F-4D97-AF65-F5344CB8AC3E}">
-        <p14:creationId xmlns:p14="http://schemas.microsoft.com/office/powerpoint/2010/main" val="3126658734"/>
+        <p14:creationId xmlns:p14="http://schemas.microsoft.com/office/powerpoint/2010/main" val="3294060455"/>
       </p:ext>
     </p:extLst>
   </p:cSld>
@@ -1441,22 +1681,7 @@
           <a:p>
             <a:r>
               <a:rPr lang="en-US" dirty="0"/>
-              <a:t>NH3/H2/air, phi 0.7, 1atm</a:t>
-            </a:r>
-          </a:p>
-          <a:p>
-            <a:r>
-              <a:rPr lang="en-US" dirty="0"/>
-              <a:t>NH3/H2/air, phi 1.3, 1atm</a:t>
-            </a:r>
-          </a:p>
-          <a:p>
-            <a:endParaRPr lang="en-US" dirty="0"/>
-          </a:p>
-          <a:p>
-            <a:r>
-              <a:rPr lang="en-US" dirty="0"/>
-              <a:t>Unable to validate for elevated pressures due to a lack of experimental  data</a:t>
+              <a:t>Operating conditions selected because substantial experimental data exists for this condition in literature</a:t>
             </a:r>
           </a:p>
         </p:txBody>
@@ -1484,7 +1709,7 @@
               <a:pPr>
                 <a:defRPr/>
               </a:pPr>
-              <a:t>11</a:t>
+              <a:t>5</a:t>
             </a:fld>
             <a:endParaRPr lang="en-US" altLang="ja-JP"/>
           </a:p>
@@ -1493,7 +1718,453 @@
     </p:spTree>
     <p:extLst>
       <p:ext uri="{BB962C8B-B14F-4D97-AF65-F5344CB8AC3E}">
-        <p14:creationId xmlns:p14="http://schemas.microsoft.com/office/powerpoint/2010/main" val="1885764697"/>
+        <p14:creationId xmlns:p14="http://schemas.microsoft.com/office/powerpoint/2010/main" val="3755310143"/>
+      </p:ext>
+    </p:extLst>
+  </p:cSld>
+  <p:clrMapOvr>
+    <a:masterClrMapping/>
+  </p:clrMapOvr>
+</p:notes>
+</file>
+
+<file path=ppt/notesSlides/notesSlide6.xml><?xml version="1.0" encoding="utf-8"?>
+<p:notes xmlns:a="http://schemas.openxmlformats.org/drawingml/2006/main" xmlns:r="http://schemas.openxmlformats.org/officeDocument/2006/relationships" xmlns:p="http://schemas.openxmlformats.org/presentationml/2006/main">
+  <p:cSld>
+    <p:spTree>
+      <p:nvGrpSpPr>
+        <p:cNvPr id="1" name=""/>
+        <p:cNvGrpSpPr/>
+        <p:nvPr/>
+      </p:nvGrpSpPr>
+      <p:grpSpPr>
+        <a:xfrm>
+          <a:off x="0" y="0"/>
+          <a:ext cx="0" cy="0"/>
+          <a:chOff x="0" y="0"/>
+          <a:chExt cx="0" cy="0"/>
+        </a:xfrm>
+      </p:grpSpPr>
+      <p:sp>
+        <p:nvSpPr>
+          <p:cNvPr id="2" name="Slide Image Placeholder 1"/>
+          <p:cNvSpPr>
+            <a:spLocks noGrp="1" noRot="1" noChangeAspect="1"/>
+          </p:cNvSpPr>
+          <p:nvPr>
+            <p:ph type="sldImg"/>
+          </p:nvPr>
+        </p:nvSpPr>
+        <p:spPr/>
+      </p:sp>
+      <p:sp>
+        <p:nvSpPr>
+          <p:cNvPr id="3" name="Notes Placeholder 2"/>
+          <p:cNvSpPr>
+            <a:spLocks noGrp="1"/>
+          </p:cNvSpPr>
+          <p:nvPr>
+            <p:ph type="body" idx="1"/>
+          </p:nvPr>
+        </p:nvSpPr>
+        <p:spPr/>
+        <p:txBody>
+          <a:bodyPr/>
+          <a:lstStyle/>
+          <a:p>
+            <a:r>
+              <a:rPr lang="en-US" dirty="0"/>
+              <a:t>Include </a:t>
+            </a:r>
+            <a:r>
+              <a:rPr lang="en-US" dirty="0" err="1"/>
+              <a:t>okafor</a:t>
+            </a:r>
+            <a:r>
+              <a:rPr lang="en-US" dirty="0"/>
+              <a:t> detailed mechanism in the figure</a:t>
+            </a:r>
+          </a:p>
+          <a:p>
+            <a:r>
+              <a:rPr lang="en-US" dirty="0"/>
+              <a:t>Mention how there is an underlying misrepresentation in </a:t>
+            </a:r>
+            <a:r>
+              <a:rPr lang="en-US" dirty="0" err="1"/>
+              <a:t>okafor</a:t>
+            </a:r>
+            <a:r>
+              <a:rPr lang="en-US" dirty="0"/>
+              <a:t> mech leading to nh3/h2 </a:t>
+            </a:r>
+            <a:r>
+              <a:rPr lang="en-US" dirty="0" err="1"/>
+              <a:t>lbv</a:t>
+            </a:r>
+            <a:r>
+              <a:rPr lang="en-US" dirty="0"/>
+              <a:t> underprediction</a:t>
+            </a:r>
+          </a:p>
+        </p:txBody>
+      </p:sp>
+      <p:sp>
+        <p:nvSpPr>
+          <p:cNvPr id="4" name="Slide Number Placeholder 3"/>
+          <p:cNvSpPr>
+            <a:spLocks noGrp="1"/>
+          </p:cNvSpPr>
+          <p:nvPr>
+            <p:ph type="sldNum" sz="quarter" idx="5"/>
+          </p:nvPr>
+        </p:nvSpPr>
+        <p:spPr/>
+        <p:txBody>
+          <a:bodyPr/>
+          <a:lstStyle/>
+          <a:p>
+            <a:pPr>
+              <a:defRPr/>
+            </a:pPr>
+            <a:fld id="{ACB89EC6-F31B-4A18-90F4-42C2071FB0B9}" type="slidenum">
+              <a:rPr lang="en-US" altLang="ja-JP" smtClean="0"/>
+              <a:pPr>
+                <a:defRPr/>
+              </a:pPr>
+              <a:t>6</a:t>
+            </a:fld>
+            <a:endParaRPr lang="en-US" altLang="ja-JP"/>
+          </a:p>
+        </p:txBody>
+      </p:sp>
+    </p:spTree>
+    <p:extLst>
+      <p:ext uri="{BB962C8B-B14F-4D97-AF65-F5344CB8AC3E}">
+        <p14:creationId xmlns:p14="http://schemas.microsoft.com/office/powerpoint/2010/main" val="2891100540"/>
+      </p:ext>
+    </p:extLst>
+  </p:cSld>
+  <p:clrMapOvr>
+    <a:masterClrMapping/>
+  </p:clrMapOvr>
+</p:notes>
+</file>
+
+<file path=ppt/notesSlides/notesSlide7.xml><?xml version="1.0" encoding="utf-8"?>
+<p:notes xmlns:a="http://schemas.openxmlformats.org/drawingml/2006/main" xmlns:r="http://schemas.openxmlformats.org/officeDocument/2006/relationships" xmlns:p="http://schemas.openxmlformats.org/presentationml/2006/main">
+  <p:cSld>
+    <p:spTree>
+      <p:nvGrpSpPr>
+        <p:cNvPr id="1" name=""/>
+        <p:cNvGrpSpPr/>
+        <p:nvPr/>
+      </p:nvGrpSpPr>
+      <p:grpSpPr>
+        <a:xfrm>
+          <a:off x="0" y="0"/>
+          <a:ext cx="0" cy="0"/>
+          <a:chOff x="0" y="0"/>
+          <a:chExt cx="0" cy="0"/>
+        </a:xfrm>
+      </p:grpSpPr>
+      <p:sp>
+        <p:nvSpPr>
+          <p:cNvPr id="2" name="Slide Image Placeholder 1"/>
+          <p:cNvSpPr>
+            <a:spLocks noGrp="1" noRot="1" noChangeAspect="1"/>
+          </p:cNvSpPr>
+          <p:nvPr>
+            <p:ph type="sldImg"/>
+          </p:nvPr>
+        </p:nvSpPr>
+        <p:spPr/>
+      </p:sp>
+      <p:sp>
+        <p:nvSpPr>
+          <p:cNvPr id="3" name="Notes Placeholder 2"/>
+          <p:cNvSpPr>
+            <a:spLocks noGrp="1"/>
+          </p:cNvSpPr>
+          <p:nvPr>
+            <p:ph type="body" idx="1"/>
+          </p:nvPr>
+        </p:nvSpPr>
+        <p:spPr/>
+        <p:txBody>
+          <a:bodyPr/>
+          <a:lstStyle/>
+          <a:p>
+            <a:r>
+              <a:rPr lang="en-US" dirty="0"/>
+              <a:t>Include use of sensitivity analysis to determine reactions important to </a:t>
+            </a:r>
+            <a:r>
+              <a:rPr lang="en-US" dirty="0" err="1"/>
+              <a:t>lbv</a:t>
+            </a:r>
+            <a:endParaRPr lang="en-US" dirty="0"/>
+          </a:p>
+        </p:txBody>
+      </p:sp>
+      <p:sp>
+        <p:nvSpPr>
+          <p:cNvPr id="4" name="Slide Number Placeholder 3"/>
+          <p:cNvSpPr>
+            <a:spLocks noGrp="1"/>
+          </p:cNvSpPr>
+          <p:nvPr>
+            <p:ph type="sldNum" sz="quarter" idx="5"/>
+          </p:nvPr>
+        </p:nvSpPr>
+        <p:spPr/>
+        <p:txBody>
+          <a:bodyPr/>
+          <a:lstStyle/>
+          <a:p>
+            <a:pPr>
+              <a:defRPr/>
+            </a:pPr>
+            <a:fld id="{ACB89EC6-F31B-4A18-90F4-42C2071FB0B9}" type="slidenum">
+              <a:rPr lang="en-US" altLang="ja-JP" smtClean="0"/>
+              <a:pPr>
+                <a:defRPr/>
+              </a:pPr>
+              <a:t>7</a:t>
+            </a:fld>
+            <a:endParaRPr lang="en-US" altLang="ja-JP"/>
+          </a:p>
+        </p:txBody>
+      </p:sp>
+    </p:spTree>
+    <p:extLst>
+      <p:ext uri="{BB962C8B-B14F-4D97-AF65-F5344CB8AC3E}">
+        <p14:creationId xmlns:p14="http://schemas.microsoft.com/office/powerpoint/2010/main" val="1149709703"/>
+      </p:ext>
+    </p:extLst>
+  </p:cSld>
+  <p:clrMapOvr>
+    <a:masterClrMapping/>
+  </p:clrMapOvr>
+</p:notes>
+</file>
+
+<file path=ppt/notesSlides/notesSlide8.xml><?xml version="1.0" encoding="utf-8"?>
+<p:notes xmlns:a="http://schemas.openxmlformats.org/drawingml/2006/main" xmlns:r="http://schemas.openxmlformats.org/officeDocument/2006/relationships" xmlns:p="http://schemas.openxmlformats.org/presentationml/2006/main">
+  <p:cSld>
+    <p:spTree>
+      <p:nvGrpSpPr>
+        <p:cNvPr id="1" name=""/>
+        <p:cNvGrpSpPr/>
+        <p:nvPr/>
+      </p:nvGrpSpPr>
+      <p:grpSpPr>
+        <a:xfrm>
+          <a:off x="0" y="0"/>
+          <a:ext cx="0" cy="0"/>
+          <a:chOff x="0" y="0"/>
+          <a:chExt cx="0" cy="0"/>
+        </a:xfrm>
+      </p:grpSpPr>
+      <p:sp>
+        <p:nvSpPr>
+          <p:cNvPr id="2" name="Slide Image Placeholder 1"/>
+          <p:cNvSpPr>
+            <a:spLocks noGrp="1" noRot="1" noChangeAspect="1"/>
+          </p:cNvSpPr>
+          <p:nvPr>
+            <p:ph type="sldImg"/>
+          </p:nvPr>
+        </p:nvSpPr>
+        <p:spPr/>
+      </p:sp>
+      <p:sp>
+        <p:nvSpPr>
+          <p:cNvPr id="3" name="Notes Placeholder 2"/>
+          <p:cNvSpPr>
+            <a:spLocks noGrp="1"/>
+          </p:cNvSpPr>
+          <p:nvPr>
+            <p:ph type="body" idx="1"/>
+          </p:nvPr>
+        </p:nvSpPr>
+        <p:spPr/>
+        <p:txBody>
+          <a:bodyPr/>
+          <a:lstStyle/>
+          <a:p>
+            <a:r>
+              <a:rPr lang="en-US" dirty="0"/>
+              <a:t>Replace (a) and (b) to names of mechanism</a:t>
+            </a:r>
+          </a:p>
+          <a:p>
+            <a:r>
+              <a:rPr lang="en-US" dirty="0"/>
+              <a:t>Remove caption</a:t>
+            </a:r>
+          </a:p>
+        </p:txBody>
+      </p:sp>
+      <p:sp>
+        <p:nvSpPr>
+          <p:cNvPr id="4" name="Slide Number Placeholder 3"/>
+          <p:cNvSpPr>
+            <a:spLocks noGrp="1"/>
+          </p:cNvSpPr>
+          <p:nvPr>
+            <p:ph type="sldNum" sz="quarter" idx="5"/>
+          </p:nvPr>
+        </p:nvSpPr>
+        <p:spPr/>
+        <p:txBody>
+          <a:bodyPr/>
+          <a:lstStyle/>
+          <a:p>
+            <a:pPr>
+              <a:defRPr/>
+            </a:pPr>
+            <a:fld id="{ACB89EC6-F31B-4A18-90F4-42C2071FB0B9}" type="slidenum">
+              <a:rPr lang="en-US" altLang="ja-JP" smtClean="0"/>
+              <a:pPr>
+                <a:defRPr/>
+              </a:pPr>
+              <a:t>8</a:t>
+            </a:fld>
+            <a:endParaRPr lang="en-US" altLang="ja-JP"/>
+          </a:p>
+        </p:txBody>
+      </p:sp>
+    </p:spTree>
+    <p:extLst>
+      <p:ext uri="{BB962C8B-B14F-4D97-AF65-F5344CB8AC3E}">
+        <p14:creationId xmlns:p14="http://schemas.microsoft.com/office/powerpoint/2010/main" val="3534912427"/>
+      </p:ext>
+    </p:extLst>
+  </p:cSld>
+  <p:clrMapOvr>
+    <a:masterClrMapping/>
+  </p:clrMapOvr>
+</p:notes>
+</file>
+
+<file path=ppt/notesSlides/notesSlide9.xml><?xml version="1.0" encoding="utf-8"?>
+<p:notes xmlns:a="http://schemas.openxmlformats.org/drawingml/2006/main" xmlns:r="http://schemas.openxmlformats.org/officeDocument/2006/relationships" xmlns:p="http://schemas.openxmlformats.org/presentationml/2006/main">
+  <p:cSld>
+    <p:spTree>
+      <p:nvGrpSpPr>
+        <p:cNvPr id="1" name=""/>
+        <p:cNvGrpSpPr/>
+        <p:nvPr/>
+      </p:nvGrpSpPr>
+      <p:grpSpPr>
+        <a:xfrm>
+          <a:off x="0" y="0"/>
+          <a:ext cx="0" cy="0"/>
+          <a:chOff x="0" y="0"/>
+          <a:chExt cx="0" cy="0"/>
+        </a:xfrm>
+      </p:grpSpPr>
+      <p:sp>
+        <p:nvSpPr>
+          <p:cNvPr id="2" name="Slide Image Placeholder 1"/>
+          <p:cNvSpPr>
+            <a:spLocks noGrp="1" noRot="1" noChangeAspect="1"/>
+          </p:cNvSpPr>
+          <p:nvPr>
+            <p:ph type="sldImg"/>
+          </p:nvPr>
+        </p:nvSpPr>
+        <p:spPr/>
+      </p:sp>
+      <p:sp>
+        <p:nvSpPr>
+          <p:cNvPr id="3" name="Notes Placeholder 2"/>
+          <p:cNvSpPr>
+            <a:spLocks noGrp="1"/>
+          </p:cNvSpPr>
+          <p:nvPr>
+            <p:ph type="body" idx="1"/>
+          </p:nvPr>
+        </p:nvSpPr>
+        <p:spPr/>
+        <p:txBody>
+          <a:bodyPr/>
+          <a:lstStyle/>
+          <a:p>
+            <a:r>
+              <a:rPr lang="en-US" dirty="0"/>
+              <a:t>Order of point 1,3 -&gt; 4 -&gt; 2</a:t>
+            </a:r>
+          </a:p>
+          <a:p>
+            <a:r>
+              <a:rPr lang="en-US" dirty="0"/>
+              <a:t>1,3 combine by NH2 &lt;-&gt; N2Hx pathway</a:t>
+            </a:r>
+          </a:p>
+          <a:p>
+            <a:r>
+              <a:rPr lang="en-US" dirty="0"/>
+              <a:t>2 express significance of NNH -&gt; N2 in H radical production by showing contribution of ROP of H via this reaction</a:t>
+            </a:r>
+          </a:p>
+          <a:p>
+            <a:endParaRPr lang="en-US" dirty="0"/>
+          </a:p>
+          <a:p>
+            <a:r>
+              <a:rPr lang="en-US" dirty="0"/>
+              <a:t>1,2,3 control H radicals conc</a:t>
+            </a:r>
+          </a:p>
+          <a:p>
+            <a:r>
+              <a:rPr lang="en-US" dirty="0"/>
+              <a:t>1,2 control NH and NH2 conc</a:t>
+            </a:r>
+          </a:p>
+          <a:p>
+            <a:r>
+              <a:rPr lang="en-US" dirty="0"/>
+              <a:t>	NHx interact with H and OH</a:t>
+            </a:r>
+          </a:p>
+        </p:txBody>
+      </p:sp>
+      <p:sp>
+        <p:nvSpPr>
+          <p:cNvPr id="4" name="Slide Number Placeholder 3"/>
+          <p:cNvSpPr>
+            <a:spLocks noGrp="1"/>
+          </p:cNvSpPr>
+          <p:nvPr>
+            <p:ph type="sldNum" sz="quarter" idx="5"/>
+          </p:nvPr>
+        </p:nvSpPr>
+        <p:spPr/>
+        <p:txBody>
+          <a:bodyPr/>
+          <a:lstStyle/>
+          <a:p>
+            <a:pPr>
+              <a:defRPr/>
+            </a:pPr>
+            <a:fld id="{ACB89EC6-F31B-4A18-90F4-42C2071FB0B9}" type="slidenum">
+              <a:rPr lang="en-US" altLang="ja-JP" smtClean="0"/>
+              <a:pPr>
+                <a:defRPr/>
+              </a:pPr>
+              <a:t>9</a:t>
+            </a:fld>
+            <a:endParaRPr lang="en-US" altLang="ja-JP"/>
+          </a:p>
+        </p:txBody>
+      </p:sp>
+    </p:spTree>
+    <p:extLst>
+      <p:ext uri="{BB962C8B-B14F-4D97-AF65-F5344CB8AC3E}">
+        <p14:creationId xmlns:p14="http://schemas.microsoft.com/office/powerpoint/2010/main" val="3126658734"/>
       </p:ext>
     </p:extLst>
   </p:cSld>
@@ -4150,7 +4821,7 @@
                 </a14:m>
                 <a:r>
                   <a:rPr lang="en-US" sz="2400" dirty="0"/>
-                  <a:t> H pathway in Gotama Mech was dominated by NNH = N2 + H</a:t>
+                  <a:t> N2 pathway in Gotama Mech was dominated by NNH = N2 + H</a:t>
                 </a:r>
               </a:p>
               <a:p>
@@ -4976,7 +5647,7 @@
           </p:nvPr>
         </p:nvPicPr>
         <p:blipFill>
-          <a:blip r:embed="rId2" cstate="print">
+          <a:blip r:embed="rId3" cstate="print">
             <a:extLst>
               <a:ext uri="{28A0092B-C50C-407E-A947-70E740481C1C}">
                 <a14:useLocalDpi xmlns:a14="http://schemas.microsoft.com/office/drawing/2010/main" val="0"/>
@@ -5120,6 +5791,9 @@
           <a:bodyPr anchor="ctr"/>
           <a:lstStyle/>
           <a:p>
+            <a:endParaRPr lang="en-GB" sz="2000" dirty="0"/>
+          </a:p>
+          <a:p>
             <a:r>
               <a:rPr lang="en-GB" sz="2000" dirty="0"/>
               <a:t>Numerically simulating ammonia blends is necessary for combustion system development.</a:t>
@@ -5131,7 +5805,7 @@
           <a:p>
             <a:r>
               <a:rPr lang="en-GB" sz="2000" dirty="0"/>
-              <a:t>Large-scale or 3D modelling with detailed chemical kinetics mechanisms increases computational cost.</a:t>
+              <a:t>Large-scale, 3D modelling with detailed chemical kinetics mechanisms increases computational cost.</a:t>
             </a:r>
           </a:p>
           <a:p>
@@ -5215,7 +5889,7 @@
               </a:pPr>
               <a:t>1</a:t>
             </a:fld>
-            <a:endParaRPr lang="en-US" altLang="ja-JP"/>
+            <a:endParaRPr lang="en-US" altLang="ja-JP" dirty="0"/>
           </a:p>
         </p:txBody>
       </p:sp>
@@ -5441,7 +6115,7 @@
           <p:nvPr/>
         </p:nvPicPr>
         <p:blipFill>
-          <a:blip r:embed="rId2" cstate="print">
+          <a:blip r:embed="rId3" cstate="print">
             <a:extLst>
               <a:ext uri="{28A0092B-C50C-407E-A947-70E740481C1C}">
                 <a14:useLocalDpi xmlns:a14="http://schemas.microsoft.com/office/drawing/2010/main" val="0"/>
@@ -5477,7 +6151,7 @@
           <p:nvPr/>
         </p:nvPicPr>
         <p:blipFill>
-          <a:blip r:embed="rId3" cstate="print">
+          <a:blip r:embed="rId4" cstate="print">
             <a:extLst>
               <a:ext uri="{28A0092B-C50C-407E-A947-70E740481C1C}">
                 <a14:useLocalDpi xmlns:a14="http://schemas.microsoft.com/office/drawing/2010/main" val="0"/>
@@ -5560,7 +6234,7 @@
           <a:blip>
             <a:extLst>
               <a:ext uri="{96DAC541-7B7A-43D3-8B79-37D633B846F1}">
-                <asvg:svgBlip xmlns:asvg="http://schemas.microsoft.com/office/drawing/2016/SVG/main" r:embed="rId4"/>
+                <asvg:svgBlip xmlns:asvg="http://schemas.microsoft.com/office/drawing/2016/SVG/main" r:embed="rId5"/>
               </a:ext>
             </a:extLst>
           </a:blip>
@@ -5762,8 +6436,8 @@
           <a:chExt cx="0" cy="0"/>
         </a:xfrm>
       </p:grpSpPr>
-      <mc:AlternateContent xmlns:mc="http://schemas.openxmlformats.org/markup-compatibility/2006" xmlns:a14="http://schemas.microsoft.com/office/drawing/2010/main">
-        <mc:Choice Requires="a14">
+      <mc:AlternateContent xmlns:mc="http://schemas.openxmlformats.org/markup-compatibility/2006">
+        <mc:Choice xmlns:a14="http://schemas.microsoft.com/office/drawing/2010/main" Requires="a14">
           <p:sp>
             <p:nvSpPr>
               <p:cNvPr id="2" name="Content Placeholder 1">
@@ -5801,21 +6475,28 @@
                 <a:pPr lvl="1"/>
                 <a:r>
                   <a:rPr lang="en-US" dirty="0"/>
-                  <a:t>Fails to model NH3/H2/air flames at hydrogen concentrations greater than </a:t>
+                  <a:t>The mechanism is not optimized for NH3/H2/air flames.</a:t>
+                </a:r>
+              </a:p>
+              <a:p>
+                <a:pPr lvl="2"/>
+                <a:r>
+                  <a:rPr lang="en-US" dirty="0"/>
+                  <a:t>Hence underpredicts flame speed when H2 concentration exceeds </a:t>
                 </a:r>
                 <a14:m>
                   <m:oMath xmlns:m="http://schemas.openxmlformats.org/officeDocument/2006/math">
                     <m:sSub>
                       <m:sSubPr>
                         <m:ctrlPr>
-                          <a:rPr lang="en-US" i="1">
+                          <a:rPr lang="en-US" b="0" i="1" smtClean="0">
                             <a:latin typeface="Cambria Math" panose="02040503050406030204" pitchFamily="18" charset="0"/>
                           </a:rPr>
                         </m:ctrlPr>
                       </m:sSubPr>
                       <m:e>
                         <m:r>
-                          <a:rPr lang="en-US" i="1">
+                          <a:rPr lang="en-US" b="0" i="1" smtClean="0">
                             <a:latin typeface="Cambria Math" panose="02040503050406030204" pitchFamily="18" charset="0"/>
                           </a:rPr>
                           <m:t>𝑋</m:t>
@@ -5826,13 +6507,13 @@
                           <m:rPr>
                             <m:sty m:val="p"/>
                           </m:rPr>
-                          <a:rPr lang="en-US">
+                          <a:rPr lang="en-US" b="0" i="0" smtClean="0">
                             <a:latin typeface="Cambria Math" panose="02040503050406030204" pitchFamily="18" charset="0"/>
                           </a:rPr>
                           <m:t>H</m:t>
                         </m:r>
                         <m:r>
-                          <a:rPr lang="en-US">
+                          <a:rPr lang="en-US" b="0" i="0" smtClean="0">
                             <a:latin typeface="Cambria Math" panose="02040503050406030204" pitchFamily="18" charset="0"/>
                           </a:rPr>
                           <m:t>2</m:t>
@@ -5840,16 +6521,10 @@
                       </m:sub>
                     </m:sSub>
                     <m:r>
-                      <a:rPr lang="en-US" b="0" i="0" smtClean="0">
+                      <a:rPr lang="en-US" b="0" i="1" smtClean="0">
                         <a:latin typeface="Cambria Math" panose="02040503050406030204" pitchFamily="18" charset="0"/>
                       </a:rPr>
-                      <m:t>=</m:t>
-                    </m:r>
-                    <m:r>
-                      <a:rPr lang="en-US">
-                        <a:latin typeface="Cambria Math" panose="02040503050406030204" pitchFamily="18" charset="0"/>
-                      </a:rPr>
-                      <m:t>0.3</m:t>
+                      <m:t>=0.3</m:t>
                     </m:r>
                   </m:oMath>
                 </a14:m>
@@ -5861,7 +6536,14 @@
               <a:p>
                 <a:r>
                   <a:rPr lang="en-US" dirty="0"/>
-                  <a:t>Reaction mechanism by Gotama et al. (2022) was used to study the differences in ammonia and hydrogen kinetics interaction.</a:t>
+                  <a:t>Underlying chemistry in NH3/H2/air flames were studied by studying reaction mechanisms developed for this blend. </a:t>
+                </a:r>
+              </a:p>
+              <a:p>
+                <a:pPr lvl="1"/>
+                <a:r>
+                  <a:rPr lang="en-US" dirty="0"/>
+                  <a:t>Reaction mechanism by Gotama et al. (2022) was optimized for laminar burning velocity of NH3/H2/air flames.</a:t>
                 </a:r>
               </a:p>
               <a:p>
@@ -5881,7 +6563,7 @@
             </p:txBody>
           </p:sp>
         </mc:Choice>
-        <mc:Fallback xmlns="">
+        <mc:Fallback>
           <p:sp>
             <p:nvSpPr>
               <p:cNvPr id="2" name="Content Placeholder 1">
@@ -5900,9 +6582,9 @@
             </p:nvSpPr>
             <p:spPr>
               <a:blipFill>
-                <a:blip r:embed="rId2"/>
+                <a:blip r:embed="rId3"/>
                 <a:stretch>
-                  <a:fillRect l="-1683" t="-2168" r="-109"/>
+                  <a:fillRect l="-1683" t="-2168" b="-3827"/>
                 </a:stretch>
               </a:blipFill>
             </p:spPr>
@@ -6022,8 +6704,8 @@
           <a:chExt cx="0" cy="0"/>
         </a:xfrm>
       </p:grpSpPr>
-      <mc:AlternateContent xmlns:mc="http://schemas.openxmlformats.org/markup-compatibility/2006" xmlns:a14="http://schemas.microsoft.com/office/drawing/2010/main">
-        <mc:Choice Requires="a14">
+      <mc:AlternateContent xmlns:mc="http://schemas.openxmlformats.org/markup-compatibility/2006">
+        <mc:Choice xmlns:a14="http://schemas.microsoft.com/office/drawing/2010/main" Requires="a14">
           <p:sp>
             <p:nvSpPr>
               <p:cNvPr id="2" name="Content Placeholder 1">
@@ -6190,7 +6872,7 @@
             </p:txBody>
           </p:sp>
         </mc:Choice>
-        <mc:Fallback xmlns="">
+        <mc:Fallback>
           <p:sp>
             <p:nvSpPr>
               <p:cNvPr id="2" name="Content Placeholder 1">
@@ -6209,7 +6891,7 @@
             </p:nvSpPr>
             <p:spPr>
               <a:blipFill>
-                <a:blip r:embed="rId2"/>
+                <a:blip r:embed="rId3"/>
                 <a:stretch>
                   <a:fillRect l="-1683" t="-2168"/>
                 </a:stretch>
@@ -6348,7 +7030,7 @@
           </p:nvPr>
         </p:nvPicPr>
         <p:blipFill>
-          <a:blip r:embed="rId2" cstate="print">
+          <a:blip r:embed="rId3" cstate="print">
             <a:extLst>
               <a:ext uri="{28A0092B-C50C-407E-A947-70E740481C1C}">
                 <a14:useLocalDpi xmlns:a14="http://schemas.microsoft.com/office/drawing/2010/main" val="0"/>
@@ -6501,8 +7183,8 @@
           <a:chExt cx="0" cy="0"/>
         </a:xfrm>
       </p:grpSpPr>
-      <mc:AlternateContent xmlns:mc="http://schemas.openxmlformats.org/markup-compatibility/2006" xmlns:a14="http://schemas.microsoft.com/office/drawing/2010/main">
-        <mc:Choice Requires="a14">
+      <mc:AlternateContent xmlns:mc="http://schemas.openxmlformats.org/markup-compatibility/2006">
+        <mc:Choice xmlns:a14="http://schemas.microsoft.com/office/drawing/2010/main" Requires="a14">
           <p:sp>
             <p:nvSpPr>
               <p:cNvPr id="2" name="Content Placeholder 1">
@@ -6526,7 +7208,46 @@
               <a:p>
                 <a:r>
                   <a:rPr lang="en-US" dirty="0"/>
-                  <a:t>Mechanisms were compared using reaction pathways constructed with integrated rate of production (IROP) of major NH3 and H2 oxidation species.</a:t>
+                  <a:t>Normalized sensitivity of </a:t>
+                </a:r>
+                <a14:m>
+                  <m:oMath xmlns:m="http://schemas.openxmlformats.org/officeDocument/2006/math">
+                    <m:sSub>
+                      <m:sSubPr>
+                        <m:ctrlPr>
+                          <a:rPr lang="en-US" b="0" i="1" smtClean="0">
+                            <a:latin typeface="Cambria Math" panose="02040503050406030204" pitchFamily="18" charset="0"/>
+                          </a:rPr>
+                        </m:ctrlPr>
+                      </m:sSubPr>
+                      <m:e>
+                        <m:r>
+                          <a:rPr lang="en-US" b="0" i="1" smtClean="0">
+                            <a:latin typeface="Cambria Math" panose="02040503050406030204" pitchFamily="18" charset="0"/>
+                          </a:rPr>
+                          <m:t>𝑆</m:t>
+                        </m:r>
+                      </m:e>
+                      <m:sub>
+                        <m:r>
+                          <a:rPr lang="en-US" b="0" i="1" smtClean="0">
+                            <a:latin typeface="Cambria Math" panose="02040503050406030204" pitchFamily="18" charset="0"/>
+                          </a:rPr>
+                          <m:t>𝐿</m:t>
+                        </m:r>
+                      </m:sub>
+                    </m:sSub>
+                  </m:oMath>
+                </a14:m>
+                <a:r>
+                  <a:rPr lang="en-US" dirty="0"/>
+                  <a:t> to rate constants of elementary reactions were analyzed.</a:t>
+                </a:r>
+              </a:p>
+              <a:p>
+                <a:r>
+                  <a:rPr lang="en-US" dirty="0"/>
+                  <a:t>Mechanisms were studied using reaction pathways constructed with integrated rate of production (IROP) of major NH3 and H2 oxidation species.</a:t>
                 </a:r>
               </a:p>
               <a:p>
@@ -6703,7 +7424,7 @@
             </p:txBody>
           </p:sp>
         </mc:Choice>
-        <mc:Fallback xmlns="">
+        <mc:Fallback>
           <p:sp>
             <p:nvSpPr>
               <p:cNvPr id="2" name="Content Placeholder 1">
@@ -6722,9 +7443,9 @@
             </p:nvSpPr>
             <p:spPr>
               <a:blipFill>
-                <a:blip r:embed="rId2"/>
+                <a:blip r:embed="rId3"/>
                 <a:stretch>
-                  <a:fillRect l="-1683" t="-2168"/>
+                  <a:fillRect l="-1683" t="-2168" r="-2172" b="-4082"/>
                 </a:stretch>
               </a:blipFill>
             </p:spPr>
@@ -6810,7 +7531,7 @@
               </a:pPr>
               <a:t>7</a:t>
             </a:fld>
-            <a:endParaRPr lang="en-US" altLang="ja-JP"/>
+            <a:endParaRPr lang="en-US" altLang="ja-JP" dirty="0"/>
           </a:p>
         </p:txBody>
       </p:sp>
@@ -6879,42 +7600,154 @@
           </a:xfrm>
         </p:spPr>
       </p:pic>
-      <p:sp>
-        <p:nvSpPr>
-          <p:cNvPr id="6" name="Footer Placeholder 5">
-            <a:extLst>
-              <a:ext uri="{FF2B5EF4-FFF2-40B4-BE49-F238E27FC236}">
-                <a16:creationId xmlns:a16="http://schemas.microsoft.com/office/drawing/2014/main" id="{DEB392FD-A7DC-53D3-86AA-59DB820A8B3D}"/>
-              </a:ext>
-            </a:extLst>
-          </p:cNvPr>
-          <p:cNvSpPr>
-            <a:spLocks noGrp="1"/>
-          </p:cNvSpPr>
-          <p:nvPr>
-            <p:ph type="ftr" sz="quarter" idx="4294967295"/>
-          </p:nvPr>
-        </p:nvSpPr>
-        <p:spPr>
-          <a:xfrm>
-            <a:off x="762000" y="260648"/>
-            <a:ext cx="10014520" cy="381000"/>
-          </a:xfrm>
-        </p:spPr>
-        <p:txBody>
-          <a:bodyPr/>
-          <a:lstStyle/>
-          <a:p>
-            <a:pPr algn="l">
-              <a:defRPr/>
-            </a:pPr>
-            <a:r>
-              <a:rPr lang="en-US" altLang="ja-JP" dirty="0"/>
-              <a:t>Development of the Present Mech</a:t>
-            </a:r>
-          </a:p>
-        </p:txBody>
-      </p:sp>
+      <mc:AlternateContent xmlns:mc="http://schemas.openxmlformats.org/markup-compatibility/2006" xmlns:a14="http://schemas.microsoft.com/office/drawing/2010/main">
+        <mc:Choice Requires="a14">
+          <p:sp>
+            <p:nvSpPr>
+              <p:cNvPr id="6" name="Footer Placeholder 5">
+                <a:extLst>
+                  <a:ext uri="{FF2B5EF4-FFF2-40B4-BE49-F238E27FC236}">
+                    <a16:creationId xmlns:a16="http://schemas.microsoft.com/office/drawing/2014/main" id="{DEB392FD-A7DC-53D3-86AA-59DB820A8B3D}"/>
+                  </a:ext>
+                </a:extLst>
+              </p:cNvPr>
+              <p:cNvSpPr>
+                <a:spLocks noGrp="1"/>
+              </p:cNvSpPr>
+              <p:nvPr>
+                <p:ph type="ftr" sz="quarter" idx="4294967295"/>
+              </p:nvPr>
+            </p:nvSpPr>
+            <p:spPr>
+              <a:xfrm>
+                <a:off x="762000" y="260648"/>
+                <a:ext cx="10014520" cy="381000"/>
+              </a:xfrm>
+            </p:spPr>
+            <p:txBody>
+              <a:bodyPr/>
+              <a:lstStyle/>
+              <a:p>
+                <a:pPr>
+                  <a:defRPr/>
+                </a:pPr>
+                <a:r>
+                  <a:rPr lang="en-US" altLang="ja-JP" dirty="0"/>
+                  <a:t>Reaction pathways of NH3/H2/air flame at </a:t>
+                </a:r>
+                <a14:m>
+                  <m:oMath xmlns:m="http://schemas.openxmlformats.org/officeDocument/2006/math">
+                    <m:sSub>
+                      <m:sSubPr>
+                        <m:ctrlPr>
+                          <a:rPr lang="en-US" sz="2400" i="1">
+                            <a:latin typeface="Cambria Math" panose="02040503050406030204" pitchFamily="18" charset="0"/>
+                          </a:rPr>
+                        </m:ctrlPr>
+                      </m:sSubPr>
+                      <m:e>
+                        <m:r>
+                          <a:rPr lang="en-US" sz="2400" i="1">
+                            <a:latin typeface="Cambria Math" panose="02040503050406030204" pitchFamily="18" charset="0"/>
+                          </a:rPr>
+                          <m:t>𝑋</m:t>
+                        </m:r>
+                      </m:e>
+                      <m:sub>
+                        <m:r>
+                          <m:rPr>
+                            <m:sty m:val="p"/>
+                          </m:rPr>
+                          <a:rPr lang="en-US" sz="2400">
+                            <a:latin typeface="Cambria Math" panose="02040503050406030204" pitchFamily="18" charset="0"/>
+                          </a:rPr>
+                          <m:t>H</m:t>
+                        </m:r>
+                        <m:r>
+                          <a:rPr lang="en-US" sz="2400">
+                            <a:latin typeface="Cambria Math" panose="02040503050406030204" pitchFamily="18" charset="0"/>
+                          </a:rPr>
+                          <m:t>2</m:t>
+                        </m:r>
+                      </m:sub>
+                    </m:sSub>
+                    <m:r>
+                      <a:rPr lang="en-US" sz="2400" i="1">
+                        <a:latin typeface="Cambria Math" panose="02040503050406030204" pitchFamily="18" charset="0"/>
+                      </a:rPr>
+                      <m:t>=0.5</m:t>
+                    </m:r>
+                  </m:oMath>
+                </a14:m>
+                <a:r>
+                  <a:rPr lang="en-US" sz="2400" dirty="0"/>
+                  <a:t> and </a:t>
+                </a:r>
+                <a14:m>
+                  <m:oMath xmlns:m="http://schemas.openxmlformats.org/officeDocument/2006/math">
+                    <m:r>
+                      <a:rPr lang="en-US" sz="2400" b="0" i="1" smtClean="0">
+                        <a:latin typeface="Cambria Math" panose="02040503050406030204" pitchFamily="18" charset="0"/>
+                      </a:rPr>
+                      <m:t>𝜙</m:t>
+                    </m:r>
+                    <m:r>
+                      <a:rPr lang="en-US" sz="2400" b="0" i="1" smtClean="0">
+                        <a:latin typeface="Cambria Math" panose="02040503050406030204" pitchFamily="18" charset="0"/>
+                      </a:rPr>
+                      <m:t>=1.0</m:t>
+                    </m:r>
+                  </m:oMath>
+                </a14:m>
+                <a:endParaRPr lang="en-US" altLang="ja-JP" dirty="0"/>
+              </a:p>
+            </p:txBody>
+          </p:sp>
+        </mc:Choice>
+        <mc:Fallback xmlns="">
+          <p:sp>
+            <p:nvSpPr>
+              <p:cNvPr id="6" name="Footer Placeholder 5">
+                <a:extLst>
+                  <a:ext uri="{FF2B5EF4-FFF2-40B4-BE49-F238E27FC236}">
+                    <a16:creationId xmlns:a16="http://schemas.microsoft.com/office/drawing/2014/main" id="{DEB392FD-A7DC-53D3-86AA-59DB820A8B3D}"/>
+                  </a:ext>
+                </a:extLst>
+              </p:cNvPr>
+              <p:cNvSpPr>
+                <a:spLocks noGrp="1" noRot="1" noChangeAspect="1" noMove="1" noResize="1" noEditPoints="1" noAdjustHandles="1" noChangeArrowheads="1" noChangeShapeType="1" noTextEdit="1"/>
+              </p:cNvSpPr>
+              <p:nvPr>
+                <p:ph type="ftr" sz="quarter" idx="4294967295"/>
+              </p:nvPr>
+            </p:nvSpPr>
+            <p:spPr>
+              <a:xfrm>
+                <a:off x="762000" y="260648"/>
+                <a:ext cx="10014520" cy="381000"/>
+              </a:xfrm>
+              <a:blipFill>
+                <a:blip r:embed="rId4"/>
+                <a:stretch>
+                  <a:fillRect l="-852" t="-11290" b="-59677"/>
+                </a:stretch>
+              </a:blipFill>
+            </p:spPr>
+            <p:txBody>
+              <a:bodyPr/>
+              <a:lstStyle/>
+              <a:p>
+                <a:r>
+                  <a:rPr lang="en-US">
+                    <a:noFill/>
+                  </a:rPr>
+                  <a:t> </a:t>
+                </a:r>
+              </a:p>
+            </p:txBody>
+          </p:sp>
+        </mc:Fallback>
+      </mc:AlternateContent>
       <p:sp>
         <p:nvSpPr>
           <p:cNvPr id="5" name="Slide Number Placeholder 4">
@@ -7069,7 +7902,7 @@
                 <a:avLst/>
               </a:prstGeom>
               <a:blipFill>
-                <a:blip r:embed="rId4"/>
+                <a:blip r:embed="rId5"/>
                 <a:stretch>
                   <a:fillRect l="-172" t="-2013" b="-6040"/>
                 </a:stretch>

</xml_diff>